<commit_message>
Match approved solid square bullet styling
</commit_message>
<xml_diff>
--- a/Teal_Editorial_Starter.pptx
+++ b/Teal_Editorial_Starter.pptx
@@ -2169,9 +2169,12 @@
               <a:spcAft>
                 <a:spcPts val="600"/>
               </a:spcAft>
-              <a:buSzPct val="115000"/>
-              <a:buFont typeface="Georgia"/>
-              <a:buChar char="▪"/>
+              <a:buClr>
+                <a:schemeClr val="accent1"/>
+              </a:buClr>
+              <a:buSzPct val="70000"/>
+              <a:buFont typeface="Arial"/>
+              <a:buChar char="■"/>
               <a:defRPr lang="en-US" sz="2025" dirty="0">
                 <a:solidFill>
                   <a:schemeClr val="dk1"/>
@@ -2188,9 +2191,12 @@
               <a:spcAft>
                 <a:spcPts val="600"/>
               </a:spcAft>
-              <a:buSzPct val="115000"/>
-              <a:buFont typeface="Georgia"/>
-              <a:buChar char="▪"/>
+              <a:buClr>
+                <a:schemeClr val="accent1"/>
+              </a:buClr>
+              <a:buSzPct val="70000"/>
+              <a:buFont typeface="Arial"/>
+              <a:buChar char="■"/>
               <a:defRPr lang="en-US" sz="2025" dirty="0">
                 <a:solidFill>
                   <a:schemeClr val="dk1"/>
@@ -2207,9 +2213,12 @@
               <a:spcAft>
                 <a:spcPts val="600"/>
               </a:spcAft>
-              <a:buSzPct val="115000"/>
-              <a:buFont typeface="Georgia"/>
-              <a:buChar char="▪"/>
+              <a:buClr>
+                <a:schemeClr val="accent1"/>
+              </a:buClr>
+              <a:buSzPct val="70000"/>
+              <a:buFont typeface="Arial"/>
+              <a:buChar char="■"/>
               <a:defRPr lang="en-US" sz="2025" dirty="0">
                 <a:solidFill>
                   <a:schemeClr val="dk1"/>
@@ -2226,9 +2235,12 @@
               <a:spcAft>
                 <a:spcPts val="600"/>
               </a:spcAft>
-              <a:buSzPct val="115000"/>
-              <a:buFont typeface="Georgia"/>
-              <a:buChar char="▪"/>
+              <a:buClr>
+                <a:schemeClr val="accent1"/>
+              </a:buClr>
+              <a:buSzPct val="70000"/>
+              <a:buFont typeface="Arial"/>
+              <a:buChar char="■"/>
               <a:defRPr lang="en-US" sz="2025" dirty="0">
                 <a:solidFill>
                   <a:schemeClr val="dk1"/>
@@ -2245,9 +2257,12 @@
               <a:spcAft>
                 <a:spcPts val="600"/>
               </a:spcAft>
-              <a:buSzPct val="115000"/>
-              <a:buFont typeface="Georgia"/>
-              <a:buChar char="▪"/>
+              <a:buClr>
+                <a:schemeClr val="accent1"/>
+              </a:buClr>
+              <a:buSzPct val="70000"/>
+              <a:buFont typeface="Arial"/>
+              <a:buChar char="■"/>
               <a:defRPr lang="en-US" sz="2025" dirty="0">
                 <a:solidFill>
                   <a:schemeClr val="dk1"/>
@@ -2264,9 +2279,12 @@
               <a:spcAft>
                 <a:spcPts val="600"/>
               </a:spcAft>
-              <a:buSzPct val="115000"/>
-              <a:buFont typeface="Georgia"/>
-              <a:buChar char="▪"/>
+              <a:buClr>
+                <a:schemeClr val="accent1"/>
+              </a:buClr>
+              <a:buSzPct val="70000"/>
+              <a:buFont typeface="Arial"/>
+              <a:buChar char="■"/>
               <a:defRPr lang="en-US" sz="2025" dirty="0">
                 <a:solidFill>
                   <a:schemeClr val="dk1"/>
@@ -2283,9 +2301,12 @@
               <a:spcAft>
                 <a:spcPts val="600"/>
               </a:spcAft>
-              <a:buSzPct val="115000"/>
-              <a:buFont typeface="Georgia"/>
-              <a:buChar char="▪"/>
+              <a:buClr>
+                <a:schemeClr val="accent1"/>
+              </a:buClr>
+              <a:buSzPct val="70000"/>
+              <a:buFont typeface="Arial"/>
+              <a:buChar char="■"/>
               <a:defRPr lang="en-US" sz="2025" dirty="0">
                 <a:solidFill>
                   <a:schemeClr val="dk1"/>
@@ -2302,9 +2323,12 @@
               <a:spcAft>
                 <a:spcPts val="600"/>
               </a:spcAft>
-              <a:buSzPct val="115000"/>
-              <a:buFont typeface="Georgia"/>
-              <a:buChar char="▪"/>
+              <a:buClr>
+                <a:schemeClr val="accent1"/>
+              </a:buClr>
+              <a:buSzPct val="70000"/>
+              <a:buFont typeface="Arial"/>
+              <a:buChar char="■"/>
               <a:defRPr lang="en-US" sz="2025" dirty="0">
                 <a:solidFill>
                   <a:schemeClr val="dk1"/>
@@ -2321,9 +2345,12 @@
               <a:spcAft>
                 <a:spcPts val="600"/>
               </a:spcAft>
-              <a:buSzPct val="115000"/>
-              <a:buFont typeface="Georgia"/>
-              <a:buChar char="▪"/>
+              <a:buClr>
+                <a:schemeClr val="accent1"/>
+              </a:buClr>
+              <a:buSzPct val="70000"/>
+              <a:buFont typeface="Arial"/>
+              <a:buChar char="■"/>
               <a:defRPr lang="en-US" sz="2025" dirty="0">
                 <a:solidFill>
                   <a:schemeClr val="dk1"/>
@@ -2340,9 +2367,12 @@
               <a:spcAft>
                 <a:spcPts val="600"/>
               </a:spcAft>
-              <a:buSzPct val="115000"/>
-              <a:buFont typeface="Georgia"/>
-              <a:buChar char="▪"/>
+              <a:buClr>
+                <a:schemeClr val="accent1"/>
+              </a:buClr>
+              <a:buSzPct val="70000"/>
+              <a:buFont typeface="Arial"/>
+              <a:buChar char="■"/>
               <a:defRPr lang="en-US" sz="2025" dirty="0">
                 <a:solidFill>
                   <a:schemeClr val="dk1"/>
@@ -2361,9 +2391,12 @@
               <a:spcAft>
                 <a:spcPts val="600"/>
               </a:spcAft>
-              <a:buSzPct val="115000"/>
-              <a:buFont typeface="Georgia"/>
-              <a:buChar char="▪"/>
+              <a:buClr>
+                <a:schemeClr val="accent1"/>
+              </a:buClr>
+              <a:buSzPct val="70000"/>
+              <a:buFont typeface="Arial"/>
+              <a:buChar char="■"/>
               <a:defRPr lang="en-US" sz="2025" dirty="0">
                 <a:solidFill>
                   <a:schemeClr val="dk1"/>
@@ -3069,9 +3102,12 @@
               <a:spcAft>
                 <a:spcPts val="600"/>
               </a:spcAft>
-              <a:buSzPct val="115000"/>
-              <a:buFont typeface="Georgia"/>
-              <a:buChar char="▪"/>
+              <a:buClr>
+                <a:schemeClr val="accent1"/>
+              </a:buClr>
+              <a:buSzPct val="70000"/>
+              <a:buFont typeface="Arial"/>
+              <a:buChar char="■"/>
               <a:defRPr lang="en-US" sz="2400" dirty="0">
                 <a:solidFill>
                   <a:schemeClr val="dk1"/>
@@ -3088,9 +3124,12 @@
               <a:spcAft>
                 <a:spcPts val="600"/>
               </a:spcAft>
-              <a:buSzPct val="115000"/>
-              <a:buFont typeface="Georgia"/>
-              <a:buChar char="▪"/>
+              <a:buClr>
+                <a:schemeClr val="accent1"/>
+              </a:buClr>
+              <a:buSzPct val="70000"/>
+              <a:buFont typeface="Arial"/>
+              <a:buChar char="■"/>
               <a:defRPr lang="en-US" sz="2400" dirty="0">
                 <a:solidFill>
                   <a:schemeClr val="dk1"/>
@@ -3107,9 +3146,12 @@
               <a:spcAft>
                 <a:spcPts val="600"/>
               </a:spcAft>
-              <a:buSzPct val="115000"/>
-              <a:buFont typeface="Georgia"/>
-              <a:buChar char="▪"/>
+              <a:buClr>
+                <a:schemeClr val="accent1"/>
+              </a:buClr>
+              <a:buSzPct val="70000"/>
+              <a:buFont typeface="Arial"/>
+              <a:buChar char="■"/>
               <a:defRPr lang="en-US" sz="2400" dirty="0">
                 <a:solidFill>
                   <a:schemeClr val="dk1"/>
@@ -3126,9 +3168,12 @@
               <a:spcAft>
                 <a:spcPts val="600"/>
               </a:spcAft>
-              <a:buSzPct val="115000"/>
-              <a:buFont typeface="Georgia"/>
-              <a:buChar char="▪"/>
+              <a:buClr>
+                <a:schemeClr val="accent1"/>
+              </a:buClr>
+              <a:buSzPct val="70000"/>
+              <a:buFont typeface="Arial"/>
+              <a:buChar char="■"/>
               <a:defRPr lang="en-US" sz="2400" dirty="0">
                 <a:solidFill>
                   <a:schemeClr val="dk1"/>
@@ -3145,9 +3190,12 @@
               <a:spcAft>
                 <a:spcPts val="600"/>
               </a:spcAft>
-              <a:buSzPct val="115000"/>
-              <a:buFont typeface="Georgia"/>
-              <a:buChar char="▪"/>
+              <a:buClr>
+                <a:schemeClr val="accent1"/>
+              </a:buClr>
+              <a:buSzPct val="70000"/>
+              <a:buFont typeface="Arial"/>
+              <a:buChar char="■"/>
               <a:defRPr lang="en-US" sz="2400" dirty="0">
                 <a:solidFill>
                   <a:schemeClr val="dk1"/>
@@ -3164,9 +3212,12 @@
               <a:spcAft>
                 <a:spcPts val="600"/>
               </a:spcAft>
-              <a:buSzPct val="115000"/>
-              <a:buFont typeface="Georgia"/>
-              <a:buChar char="▪"/>
+              <a:buClr>
+                <a:schemeClr val="accent1"/>
+              </a:buClr>
+              <a:buSzPct val="70000"/>
+              <a:buFont typeface="Arial"/>
+              <a:buChar char="■"/>
               <a:defRPr lang="en-US" sz="2400" dirty="0">
                 <a:solidFill>
                   <a:schemeClr val="dk1"/>
@@ -3183,9 +3234,12 @@
               <a:spcAft>
                 <a:spcPts val="600"/>
               </a:spcAft>
-              <a:buSzPct val="115000"/>
-              <a:buFont typeface="Georgia"/>
-              <a:buChar char="▪"/>
+              <a:buClr>
+                <a:schemeClr val="accent1"/>
+              </a:buClr>
+              <a:buSzPct val="70000"/>
+              <a:buFont typeface="Arial"/>
+              <a:buChar char="■"/>
               <a:defRPr lang="en-US" sz="2400" dirty="0">
                 <a:solidFill>
                   <a:schemeClr val="dk1"/>
@@ -3202,9 +3256,12 @@
               <a:spcAft>
                 <a:spcPts val="600"/>
               </a:spcAft>
-              <a:buSzPct val="115000"/>
-              <a:buFont typeface="Georgia"/>
-              <a:buChar char="▪"/>
+              <a:buClr>
+                <a:schemeClr val="accent1"/>
+              </a:buClr>
+              <a:buSzPct val="70000"/>
+              <a:buFont typeface="Arial"/>
+              <a:buChar char="■"/>
               <a:defRPr lang="en-US" sz="2400" dirty="0">
                 <a:solidFill>
                   <a:schemeClr val="dk1"/>
@@ -3221,9 +3278,12 @@
               <a:spcAft>
                 <a:spcPts val="600"/>
               </a:spcAft>
-              <a:buSzPct val="115000"/>
-              <a:buFont typeface="Georgia"/>
-              <a:buChar char="▪"/>
+              <a:buClr>
+                <a:schemeClr val="accent1"/>
+              </a:buClr>
+              <a:buSzPct val="70000"/>
+              <a:buFont typeface="Arial"/>
+              <a:buChar char="■"/>
               <a:defRPr lang="en-US" sz="2400" dirty="0">
                 <a:solidFill>
                   <a:schemeClr val="dk1"/>
@@ -3240,9 +3300,12 @@
               <a:spcAft>
                 <a:spcPts val="600"/>
               </a:spcAft>
-              <a:buSzPct val="115000"/>
-              <a:buFont typeface="Georgia"/>
-              <a:buChar char="▪"/>
+              <a:buClr>
+                <a:schemeClr val="accent1"/>
+              </a:buClr>
+              <a:buSzPct val="70000"/>
+              <a:buFont typeface="Arial"/>
+              <a:buChar char="■"/>
               <a:defRPr lang="en-US" sz="2400" dirty="0">
                 <a:solidFill>
                   <a:schemeClr val="dk1"/>
@@ -3261,9 +3324,12 @@
               <a:spcAft>
                 <a:spcPts val="600"/>
               </a:spcAft>
-              <a:buSzPct val="115000"/>
-              <a:buFont typeface="Georgia"/>
-              <a:buChar char="▪"/>
+              <a:buClr>
+                <a:schemeClr val="accent1"/>
+              </a:buClr>
+              <a:buSzPct val="70000"/>
+              <a:buFont typeface="Arial"/>
+              <a:buChar char="■"/>
               <a:defRPr lang="en-US" sz="2400" dirty="0">
                 <a:solidFill>
                   <a:schemeClr val="dk1"/>
@@ -6445,9 +6511,10 @@
               <a:spcAft>
                 <a:spcPts val="600"/>
               </a:spcAft>
-              <a:buSzPct val="135000"/>
-              <a:buFont typeface="Georgia"/>
-              <a:buChar char="▪"/>
+              <a:buClrTx/>
+              <a:buSzPct val="70000"/>
+              <a:buFont typeface="Arial"/>
+              <a:buChar char="■"/>
               <a:defRPr lang="en-US" sz="2600" dirty="0">
                 <a:solidFill>
                   <a:schemeClr val="bg1"/>
@@ -6463,9 +6530,10 @@
               <a:spcAft>
                 <a:spcPts val="600"/>
               </a:spcAft>
-              <a:buSzPct val="135000"/>
-              <a:buFont typeface="Georgia"/>
-              <a:buChar char="▪"/>
+              <a:buClrTx/>
+              <a:buSzPct val="70000"/>
+              <a:buFont typeface="Arial"/>
+              <a:buChar char="■"/>
               <a:defRPr lang="en-US" sz="2600" dirty="0">
                 <a:solidFill>
                   <a:schemeClr val="bg1"/>
@@ -6481,9 +6549,10 @@
               <a:spcAft>
                 <a:spcPts val="600"/>
               </a:spcAft>
-              <a:buSzPct val="135000"/>
-              <a:buFont typeface="Georgia"/>
-              <a:buChar char="▪"/>
+              <a:buClrTx/>
+              <a:buSzPct val="70000"/>
+              <a:buFont typeface="Arial"/>
+              <a:buChar char="■"/>
               <a:defRPr lang="en-US" sz="2600" dirty="0">
                 <a:solidFill>
                   <a:schemeClr val="bg1"/>
@@ -6499,9 +6568,10 @@
               <a:spcAft>
                 <a:spcPts val="600"/>
               </a:spcAft>
-              <a:buSzPct val="135000"/>
-              <a:buFont typeface="Georgia"/>
-              <a:buChar char="▪"/>
+              <a:buClrTx/>
+              <a:buSzPct val="70000"/>
+              <a:buFont typeface="Arial"/>
+              <a:buChar char="■"/>
               <a:defRPr lang="en-US" sz="2600" dirty="0">
                 <a:solidFill>
                   <a:schemeClr val="bg1"/>
@@ -6517,9 +6587,10 @@
               <a:spcAft>
                 <a:spcPts val="600"/>
               </a:spcAft>
-              <a:buSzPct val="135000"/>
-              <a:buFont typeface="Georgia"/>
-              <a:buChar char="▪"/>
+              <a:buClrTx/>
+              <a:buSzPct val="70000"/>
+              <a:buFont typeface="Arial"/>
+              <a:buChar char="■"/>
               <a:defRPr lang="en-US" sz="2600" dirty="0">
                 <a:solidFill>
                   <a:schemeClr val="bg1"/>
@@ -6535,9 +6606,10 @@
               <a:spcAft>
                 <a:spcPts val="600"/>
               </a:spcAft>
-              <a:buSzPct val="135000"/>
-              <a:buFont typeface="Georgia"/>
-              <a:buChar char="▪"/>
+              <a:buClrTx/>
+              <a:buSzPct val="70000"/>
+              <a:buFont typeface="Arial"/>
+              <a:buChar char="■"/>
               <a:defRPr lang="en-US" sz="2600" dirty="0">
                 <a:solidFill>
                   <a:schemeClr val="bg1"/>
@@ -6553,9 +6625,10 @@
               <a:spcAft>
                 <a:spcPts val="600"/>
               </a:spcAft>
-              <a:buSzPct val="135000"/>
-              <a:buFont typeface="Georgia"/>
-              <a:buChar char="▪"/>
+              <a:buClrTx/>
+              <a:buSzPct val="70000"/>
+              <a:buFont typeface="Arial"/>
+              <a:buChar char="■"/>
               <a:defRPr lang="en-US" sz="2600" dirty="0">
                 <a:solidFill>
                   <a:schemeClr val="bg1"/>
@@ -6571,9 +6644,10 @@
               <a:spcAft>
                 <a:spcPts val="600"/>
               </a:spcAft>
-              <a:buSzPct val="135000"/>
-              <a:buFont typeface="Georgia"/>
-              <a:buChar char="▪"/>
+              <a:buClrTx/>
+              <a:buSzPct val="70000"/>
+              <a:buFont typeface="Arial"/>
+              <a:buChar char="■"/>
               <a:defRPr lang="en-US" sz="2600" dirty="0">
                 <a:solidFill>
                   <a:schemeClr val="bg1"/>
@@ -6589,9 +6663,10 @@
               <a:spcAft>
                 <a:spcPts val="600"/>
               </a:spcAft>
-              <a:buSzPct val="135000"/>
-              <a:buFont typeface="Georgia"/>
-              <a:buChar char="▪"/>
+              <a:buClrTx/>
+              <a:buSzPct val="70000"/>
+              <a:buFont typeface="Arial"/>
+              <a:buChar char="■"/>
               <a:defRPr lang="en-US" sz="2600" dirty="0">
                 <a:solidFill>
                   <a:schemeClr val="bg1"/>
@@ -6607,9 +6682,10 @@
               <a:spcAft>
                 <a:spcPts val="600"/>
               </a:spcAft>
-              <a:buSzPct val="135000"/>
-              <a:buFont typeface="Georgia"/>
-              <a:buChar char="▪"/>
+              <a:buClrTx/>
+              <a:buSzPct val="70000"/>
+              <a:buFont typeface="Arial"/>
+              <a:buChar char="■"/>
               <a:defRPr lang="en-US" sz="2600" dirty="0">
                 <a:solidFill>
                   <a:schemeClr val="bg1"/>
@@ -6627,9 +6703,10 @@
               <a:spcAft>
                 <a:spcPts val="600"/>
               </a:spcAft>
-              <a:buSzPct val="135000"/>
-              <a:buFont typeface="Georgia"/>
-              <a:buChar char="▪"/>
+              <a:buClrTx/>
+              <a:buSzPct val="70000"/>
+              <a:buFont typeface="Arial"/>
+              <a:buChar char="■"/>
               <a:defRPr lang="en-US" sz="2600" dirty="0">
                 <a:solidFill>
                   <a:schemeClr val="bg1"/>
@@ -6929,9 +7006,12 @@
               <a:spcAft>
                 <a:spcPts val="600"/>
               </a:spcAft>
-              <a:buSzPct val="135000"/>
-              <a:buFont typeface="Georgia"/>
-              <a:buChar char="▪"/>
+              <a:buClr>
+                <a:schemeClr val="accent1"/>
+              </a:buClr>
+              <a:buSzPct val="70000"/>
+              <a:buFont typeface="Arial"/>
+              <a:buChar char="■"/>
               <a:defRPr lang="en-US" sz="2600" dirty="0">
                 <a:solidFill>
                   <a:schemeClr val="dk1"/>
@@ -6948,9 +7028,12 @@
               <a:spcAft>
                 <a:spcPts val="600"/>
               </a:spcAft>
-              <a:buSzPct val="135000"/>
-              <a:buFont typeface="Georgia"/>
-              <a:buChar char="▪"/>
+              <a:buClr>
+                <a:schemeClr val="accent1"/>
+              </a:buClr>
+              <a:buSzPct val="70000"/>
+              <a:buFont typeface="Arial"/>
+              <a:buChar char="■"/>
               <a:defRPr lang="en-US" sz="2600" dirty="0">
                 <a:solidFill>
                   <a:schemeClr val="dk1"/>
@@ -6967,9 +7050,12 @@
               <a:spcAft>
                 <a:spcPts val="600"/>
               </a:spcAft>
-              <a:buSzPct val="135000"/>
-              <a:buFont typeface="Georgia"/>
-              <a:buChar char="▪"/>
+              <a:buClr>
+                <a:schemeClr val="accent1"/>
+              </a:buClr>
+              <a:buSzPct val="70000"/>
+              <a:buFont typeface="Arial"/>
+              <a:buChar char="■"/>
               <a:defRPr lang="en-US" sz="2600" dirty="0">
                 <a:solidFill>
                   <a:schemeClr val="dk1"/>
@@ -6986,9 +7072,12 @@
               <a:spcAft>
                 <a:spcPts val="600"/>
               </a:spcAft>
-              <a:buSzPct val="135000"/>
-              <a:buFont typeface="Georgia"/>
-              <a:buChar char="▪"/>
+              <a:buClr>
+                <a:schemeClr val="accent1"/>
+              </a:buClr>
+              <a:buSzPct val="70000"/>
+              <a:buFont typeface="Arial"/>
+              <a:buChar char="■"/>
               <a:defRPr lang="en-US" sz="2600" dirty="0">
                 <a:solidFill>
                   <a:schemeClr val="dk1"/>
@@ -7005,9 +7094,12 @@
               <a:spcAft>
                 <a:spcPts val="600"/>
               </a:spcAft>
-              <a:buSzPct val="135000"/>
-              <a:buFont typeface="Georgia"/>
-              <a:buChar char="▪"/>
+              <a:buClr>
+                <a:schemeClr val="accent1"/>
+              </a:buClr>
+              <a:buSzPct val="70000"/>
+              <a:buFont typeface="Arial"/>
+              <a:buChar char="■"/>
               <a:defRPr lang="en-US" sz="2600" dirty="0">
                 <a:solidFill>
                   <a:schemeClr val="dk1"/>
@@ -7024,9 +7116,12 @@
               <a:spcAft>
                 <a:spcPts val="600"/>
               </a:spcAft>
-              <a:buSzPct val="135000"/>
-              <a:buFont typeface="Georgia"/>
-              <a:buChar char="▪"/>
+              <a:buClr>
+                <a:schemeClr val="accent1"/>
+              </a:buClr>
+              <a:buSzPct val="70000"/>
+              <a:buFont typeface="Arial"/>
+              <a:buChar char="■"/>
               <a:defRPr lang="en-US" sz="2600" dirty="0">
                 <a:solidFill>
                   <a:schemeClr val="dk1"/>
@@ -7043,9 +7138,12 @@
               <a:spcAft>
                 <a:spcPts val="600"/>
               </a:spcAft>
-              <a:buSzPct val="135000"/>
-              <a:buFont typeface="Georgia"/>
-              <a:buChar char="▪"/>
+              <a:buClr>
+                <a:schemeClr val="accent1"/>
+              </a:buClr>
+              <a:buSzPct val="70000"/>
+              <a:buFont typeface="Arial"/>
+              <a:buChar char="■"/>
               <a:defRPr lang="en-US" sz="2600" dirty="0">
                 <a:solidFill>
                   <a:schemeClr val="dk1"/>
@@ -7062,9 +7160,12 @@
               <a:spcAft>
                 <a:spcPts val="600"/>
               </a:spcAft>
-              <a:buSzPct val="135000"/>
-              <a:buFont typeface="Georgia"/>
-              <a:buChar char="▪"/>
+              <a:buClr>
+                <a:schemeClr val="accent1"/>
+              </a:buClr>
+              <a:buSzPct val="70000"/>
+              <a:buFont typeface="Arial"/>
+              <a:buChar char="■"/>
               <a:defRPr lang="en-US" sz="2600" dirty="0">
                 <a:solidFill>
                   <a:schemeClr val="dk1"/>
@@ -7081,9 +7182,12 @@
               <a:spcAft>
                 <a:spcPts val="600"/>
               </a:spcAft>
-              <a:buSzPct val="135000"/>
-              <a:buFont typeface="Georgia"/>
-              <a:buChar char="▪"/>
+              <a:buClr>
+                <a:schemeClr val="accent1"/>
+              </a:buClr>
+              <a:buSzPct val="70000"/>
+              <a:buFont typeface="Arial"/>
+              <a:buChar char="■"/>
               <a:defRPr lang="en-US" sz="2600" dirty="0">
                 <a:solidFill>
                   <a:schemeClr val="dk1"/>
@@ -7100,9 +7204,12 @@
               <a:spcAft>
                 <a:spcPts val="600"/>
               </a:spcAft>
-              <a:buSzPct val="135000"/>
-              <a:buFont typeface="Georgia"/>
-              <a:buChar char="▪"/>
+              <a:buClr>
+                <a:schemeClr val="accent1"/>
+              </a:buClr>
+              <a:buSzPct val="70000"/>
+              <a:buFont typeface="Arial"/>
+              <a:buChar char="■"/>
               <a:defRPr lang="en-US" sz="2600" dirty="0">
                 <a:solidFill>
                   <a:schemeClr val="dk1"/>
@@ -7121,9 +7228,12 @@
               <a:spcAft>
                 <a:spcPts val="600"/>
               </a:spcAft>
-              <a:buSzPct val="135000"/>
-              <a:buFont typeface="Georgia"/>
-              <a:buChar char="▪"/>
+              <a:buClr>
+                <a:schemeClr val="accent1"/>
+              </a:buClr>
+              <a:buSzPct val="70000"/>
+              <a:buFont typeface="Arial"/>
+              <a:buChar char="■"/>
               <a:defRPr lang="en-US" sz="2600" dirty="0">
                 <a:solidFill>
                   <a:schemeClr val="dk1"/>
@@ -12956,9 +13066,12 @@
               <a:spcAft>
                 <a:spcPts val="600"/>
               </a:spcAft>
-              <a:buSzPct val="115000"/>
-              <a:buFont typeface="Georgia"/>
-              <a:buChar char="▪"/>
+              <a:buClr>
+                <a:schemeClr val="accent1"/>
+              </a:buClr>
+              <a:buSzPct val="70000"/>
+              <a:buFont typeface="Arial"/>
+              <a:buChar char="■"/>
               <a:defRPr lang="en-US" sz="2400" dirty="0">
                 <a:solidFill>
                   <a:schemeClr val="dk1"/>
@@ -12975,9 +13088,12 @@
               <a:spcAft>
                 <a:spcPts val="600"/>
               </a:spcAft>
-              <a:buSzPct val="115000"/>
-              <a:buFont typeface="Georgia"/>
-              <a:buChar char="▪"/>
+              <a:buClr>
+                <a:schemeClr val="accent1"/>
+              </a:buClr>
+              <a:buSzPct val="70000"/>
+              <a:buFont typeface="Arial"/>
+              <a:buChar char="■"/>
               <a:defRPr lang="en-US" sz="2400" dirty="0">
                 <a:solidFill>
                   <a:schemeClr val="dk1"/>
@@ -12994,9 +13110,12 @@
               <a:spcAft>
                 <a:spcPts val="600"/>
               </a:spcAft>
-              <a:buSzPct val="115000"/>
-              <a:buFont typeface="Georgia"/>
-              <a:buChar char="▪"/>
+              <a:buClr>
+                <a:schemeClr val="accent1"/>
+              </a:buClr>
+              <a:buSzPct val="70000"/>
+              <a:buFont typeface="Arial"/>
+              <a:buChar char="■"/>
               <a:defRPr lang="en-US" sz="2400" dirty="0">
                 <a:solidFill>
                   <a:schemeClr val="dk1"/>
@@ -13013,9 +13132,12 @@
               <a:spcAft>
                 <a:spcPts val="600"/>
               </a:spcAft>
-              <a:buSzPct val="115000"/>
-              <a:buFont typeface="Georgia"/>
-              <a:buChar char="▪"/>
+              <a:buClr>
+                <a:schemeClr val="accent1"/>
+              </a:buClr>
+              <a:buSzPct val="70000"/>
+              <a:buFont typeface="Arial"/>
+              <a:buChar char="■"/>
               <a:defRPr lang="en-US" sz="2400" dirty="0">
                 <a:solidFill>
                   <a:schemeClr val="dk1"/>
@@ -13032,9 +13154,12 @@
               <a:spcAft>
                 <a:spcPts val="600"/>
               </a:spcAft>
-              <a:buSzPct val="115000"/>
-              <a:buFont typeface="Georgia"/>
-              <a:buChar char="▪"/>
+              <a:buClr>
+                <a:schemeClr val="accent1"/>
+              </a:buClr>
+              <a:buSzPct val="70000"/>
+              <a:buFont typeface="Arial"/>
+              <a:buChar char="■"/>
               <a:defRPr lang="en-US" sz="2400" dirty="0">
                 <a:solidFill>
                   <a:schemeClr val="dk1"/>
@@ -13051,9 +13176,12 @@
               <a:spcAft>
                 <a:spcPts val="600"/>
               </a:spcAft>
-              <a:buSzPct val="115000"/>
-              <a:buFont typeface="Georgia"/>
-              <a:buChar char="▪"/>
+              <a:buClr>
+                <a:schemeClr val="accent1"/>
+              </a:buClr>
+              <a:buSzPct val="70000"/>
+              <a:buFont typeface="Arial"/>
+              <a:buChar char="■"/>
               <a:defRPr lang="en-US" sz="2400" dirty="0">
                 <a:solidFill>
                   <a:schemeClr val="dk1"/>
@@ -13070,9 +13198,12 @@
               <a:spcAft>
                 <a:spcPts val="600"/>
               </a:spcAft>
-              <a:buSzPct val="115000"/>
-              <a:buFont typeface="Georgia"/>
-              <a:buChar char="▪"/>
+              <a:buClr>
+                <a:schemeClr val="accent1"/>
+              </a:buClr>
+              <a:buSzPct val="70000"/>
+              <a:buFont typeface="Arial"/>
+              <a:buChar char="■"/>
               <a:defRPr lang="en-US" sz="2400" dirty="0">
                 <a:solidFill>
                   <a:schemeClr val="dk1"/>
@@ -13089,9 +13220,12 @@
               <a:spcAft>
                 <a:spcPts val="600"/>
               </a:spcAft>
-              <a:buSzPct val="115000"/>
-              <a:buFont typeface="Georgia"/>
-              <a:buChar char="▪"/>
+              <a:buClr>
+                <a:schemeClr val="accent1"/>
+              </a:buClr>
+              <a:buSzPct val="70000"/>
+              <a:buFont typeface="Arial"/>
+              <a:buChar char="■"/>
               <a:defRPr lang="en-US" sz="2400" dirty="0">
                 <a:solidFill>
                   <a:schemeClr val="dk1"/>
@@ -13108,9 +13242,12 @@
               <a:spcAft>
                 <a:spcPts val="600"/>
               </a:spcAft>
-              <a:buSzPct val="115000"/>
-              <a:buFont typeface="Georgia"/>
-              <a:buChar char="▪"/>
+              <a:buClr>
+                <a:schemeClr val="accent1"/>
+              </a:buClr>
+              <a:buSzPct val="70000"/>
+              <a:buFont typeface="Arial"/>
+              <a:buChar char="■"/>
               <a:defRPr lang="en-US" sz="2400" dirty="0">
                 <a:solidFill>
                   <a:schemeClr val="dk1"/>
@@ -13127,9 +13264,12 @@
               <a:spcAft>
                 <a:spcPts val="600"/>
               </a:spcAft>
-              <a:buSzPct val="115000"/>
-              <a:buFont typeface="Georgia"/>
-              <a:buChar char="▪"/>
+              <a:buClr>
+                <a:schemeClr val="accent1"/>
+              </a:buClr>
+              <a:buSzPct val="70000"/>
+              <a:buFont typeface="Arial"/>
+              <a:buChar char="■"/>
               <a:defRPr lang="en-US" sz="2400" dirty="0">
                 <a:solidFill>
                   <a:schemeClr val="dk1"/>
@@ -13148,9 +13288,12 @@
               <a:spcAft>
                 <a:spcPts val="600"/>
               </a:spcAft>
-              <a:buSzPct val="115000"/>
-              <a:buFont typeface="Georgia"/>
-              <a:buChar char="▪"/>
+              <a:buClr>
+                <a:schemeClr val="accent1"/>
+              </a:buClr>
+              <a:buSzPct val="70000"/>
+              <a:buFont typeface="Arial"/>
+              <a:buChar char="■"/>
               <a:defRPr lang="en-US" sz="2400" dirty="0">
                 <a:solidFill>
                   <a:schemeClr val="dk1"/>
@@ -13454,9 +13597,12 @@
               <a:spcAft>
                 <a:spcPts val="600"/>
               </a:spcAft>
-              <a:buSzPct val="115000"/>
-              <a:buFont typeface="Georgia"/>
-              <a:buChar char="▪"/>
+              <a:buClr>
+                <a:schemeClr val="accent1"/>
+              </a:buClr>
+              <a:buSzPct val="70000"/>
+              <a:buFont typeface="Arial"/>
+              <a:buChar char="■"/>
               <a:defRPr lang="en-US" sz="2400" dirty="0">
                 <a:solidFill>
                   <a:schemeClr val="dk1"/>
@@ -13473,9 +13619,12 @@
               <a:spcAft>
                 <a:spcPts val="600"/>
               </a:spcAft>
-              <a:buSzPct val="115000"/>
-              <a:buFont typeface="Georgia"/>
-              <a:buChar char="▪"/>
+              <a:buClr>
+                <a:schemeClr val="accent1"/>
+              </a:buClr>
+              <a:buSzPct val="70000"/>
+              <a:buFont typeface="Arial"/>
+              <a:buChar char="■"/>
               <a:defRPr lang="en-US" sz="2400" dirty="0">
                 <a:solidFill>
                   <a:schemeClr val="dk1"/>
@@ -13492,9 +13641,12 @@
               <a:spcAft>
                 <a:spcPts val="600"/>
               </a:spcAft>
-              <a:buSzPct val="115000"/>
-              <a:buFont typeface="Georgia"/>
-              <a:buChar char="▪"/>
+              <a:buClr>
+                <a:schemeClr val="accent1"/>
+              </a:buClr>
+              <a:buSzPct val="70000"/>
+              <a:buFont typeface="Arial"/>
+              <a:buChar char="■"/>
               <a:defRPr lang="en-US" sz="2400" dirty="0">
                 <a:solidFill>
                   <a:schemeClr val="dk1"/>
@@ -13511,9 +13663,12 @@
               <a:spcAft>
                 <a:spcPts val="600"/>
               </a:spcAft>
-              <a:buSzPct val="115000"/>
-              <a:buFont typeface="Georgia"/>
-              <a:buChar char="▪"/>
+              <a:buClr>
+                <a:schemeClr val="accent1"/>
+              </a:buClr>
+              <a:buSzPct val="70000"/>
+              <a:buFont typeface="Arial"/>
+              <a:buChar char="■"/>
               <a:defRPr lang="en-US" sz="2400" dirty="0">
                 <a:solidFill>
                   <a:schemeClr val="dk1"/>
@@ -13530,9 +13685,12 @@
               <a:spcAft>
                 <a:spcPts val="600"/>
               </a:spcAft>
-              <a:buSzPct val="115000"/>
-              <a:buFont typeface="Georgia"/>
-              <a:buChar char="▪"/>
+              <a:buClr>
+                <a:schemeClr val="accent1"/>
+              </a:buClr>
+              <a:buSzPct val="70000"/>
+              <a:buFont typeface="Arial"/>
+              <a:buChar char="■"/>
               <a:defRPr lang="en-US" sz="2400" dirty="0">
                 <a:solidFill>
                   <a:schemeClr val="dk1"/>
@@ -13549,9 +13707,12 @@
               <a:spcAft>
                 <a:spcPts val="600"/>
               </a:spcAft>
-              <a:buSzPct val="115000"/>
-              <a:buFont typeface="Georgia"/>
-              <a:buChar char="▪"/>
+              <a:buClr>
+                <a:schemeClr val="accent1"/>
+              </a:buClr>
+              <a:buSzPct val="70000"/>
+              <a:buFont typeface="Arial"/>
+              <a:buChar char="■"/>
               <a:defRPr lang="en-US" sz="2400" dirty="0">
                 <a:solidFill>
                   <a:schemeClr val="dk1"/>
@@ -13568,9 +13729,12 @@
               <a:spcAft>
                 <a:spcPts val="600"/>
               </a:spcAft>
-              <a:buSzPct val="115000"/>
-              <a:buFont typeface="Georgia"/>
-              <a:buChar char="▪"/>
+              <a:buClr>
+                <a:schemeClr val="accent1"/>
+              </a:buClr>
+              <a:buSzPct val="70000"/>
+              <a:buFont typeface="Arial"/>
+              <a:buChar char="■"/>
               <a:defRPr lang="en-US" sz="2400" dirty="0">
                 <a:solidFill>
                   <a:schemeClr val="dk1"/>
@@ -13587,9 +13751,12 @@
               <a:spcAft>
                 <a:spcPts val="600"/>
               </a:spcAft>
-              <a:buSzPct val="115000"/>
-              <a:buFont typeface="Georgia"/>
-              <a:buChar char="▪"/>
+              <a:buClr>
+                <a:schemeClr val="accent1"/>
+              </a:buClr>
+              <a:buSzPct val="70000"/>
+              <a:buFont typeface="Arial"/>
+              <a:buChar char="■"/>
               <a:defRPr lang="en-US" sz="2400" dirty="0">
                 <a:solidFill>
                   <a:schemeClr val="dk1"/>
@@ -13606,9 +13773,12 @@
               <a:spcAft>
                 <a:spcPts val="600"/>
               </a:spcAft>
-              <a:buSzPct val="115000"/>
-              <a:buFont typeface="Georgia"/>
-              <a:buChar char="▪"/>
+              <a:buClr>
+                <a:schemeClr val="accent1"/>
+              </a:buClr>
+              <a:buSzPct val="70000"/>
+              <a:buFont typeface="Arial"/>
+              <a:buChar char="■"/>
               <a:defRPr lang="en-US" sz="2400" dirty="0">
                 <a:solidFill>
                   <a:schemeClr val="dk1"/>
@@ -13625,9 +13795,12 @@
               <a:spcAft>
                 <a:spcPts val="600"/>
               </a:spcAft>
-              <a:buSzPct val="115000"/>
-              <a:buFont typeface="Georgia"/>
-              <a:buChar char="▪"/>
+              <a:buClr>
+                <a:schemeClr val="accent1"/>
+              </a:buClr>
+              <a:buSzPct val="70000"/>
+              <a:buFont typeface="Arial"/>
+              <a:buChar char="■"/>
               <a:defRPr lang="en-US" sz="2400" dirty="0">
                 <a:solidFill>
                   <a:schemeClr val="dk1"/>
@@ -13646,9 +13819,12 @@
               <a:spcAft>
                 <a:spcPts val="600"/>
               </a:spcAft>
-              <a:buSzPct val="115000"/>
-              <a:buFont typeface="Georgia"/>
-              <a:buChar char="▪"/>
+              <a:buClr>
+                <a:schemeClr val="accent1"/>
+              </a:buClr>
+              <a:buSzPct val="70000"/>
+              <a:buFont typeface="Arial"/>
+              <a:buChar char="■"/>
               <a:defRPr lang="en-US" sz="2400" dirty="0">
                 <a:solidFill>
                   <a:schemeClr val="dk1"/>
@@ -17384,9 +17560,12 @@
               <a:spcAft>
                 <a:spcPts val="600"/>
               </a:spcAft>
-              <a:buSzPct val="115000"/>
-              <a:buFont typeface="Georgia"/>
-              <a:buChar char="▪"/>
+              <a:buClr>
+                <a:schemeClr val="accent1"/>
+              </a:buClr>
+              <a:buSzPct val="70000"/>
+              <a:buFont typeface="Arial"/>
+              <a:buChar char="■"/>
               <a:defRPr lang="en-US" sz="2400" dirty="0">
                 <a:solidFill>
                   <a:schemeClr val="dk1"/>
@@ -17403,9 +17582,12 @@
               <a:spcAft>
                 <a:spcPts val="600"/>
               </a:spcAft>
-              <a:buSzPct val="115000"/>
-              <a:buFont typeface="Georgia"/>
-              <a:buChar char="▪"/>
+              <a:buClr>
+                <a:schemeClr val="accent1"/>
+              </a:buClr>
+              <a:buSzPct val="70000"/>
+              <a:buFont typeface="Arial"/>
+              <a:buChar char="■"/>
               <a:defRPr lang="en-US" sz="2400" dirty="0">
                 <a:solidFill>
                   <a:schemeClr val="dk1"/>
@@ -17422,9 +17604,12 @@
               <a:spcAft>
                 <a:spcPts val="600"/>
               </a:spcAft>
-              <a:buSzPct val="115000"/>
-              <a:buFont typeface="Georgia"/>
-              <a:buChar char="▪"/>
+              <a:buClr>
+                <a:schemeClr val="accent1"/>
+              </a:buClr>
+              <a:buSzPct val="70000"/>
+              <a:buFont typeface="Arial"/>
+              <a:buChar char="■"/>
               <a:defRPr lang="en-US" sz="2400" dirty="0">
                 <a:solidFill>
                   <a:schemeClr val="dk1"/>
@@ -17441,9 +17626,12 @@
               <a:spcAft>
                 <a:spcPts val="600"/>
               </a:spcAft>
-              <a:buSzPct val="115000"/>
-              <a:buFont typeface="Georgia"/>
-              <a:buChar char="▪"/>
+              <a:buClr>
+                <a:schemeClr val="accent1"/>
+              </a:buClr>
+              <a:buSzPct val="70000"/>
+              <a:buFont typeface="Arial"/>
+              <a:buChar char="■"/>
               <a:defRPr lang="en-US" sz="2400" dirty="0">
                 <a:solidFill>
                   <a:schemeClr val="dk1"/>
@@ -17460,9 +17648,12 @@
               <a:spcAft>
                 <a:spcPts val="600"/>
               </a:spcAft>
-              <a:buSzPct val="115000"/>
-              <a:buFont typeface="Georgia"/>
-              <a:buChar char="▪"/>
+              <a:buClr>
+                <a:schemeClr val="accent1"/>
+              </a:buClr>
+              <a:buSzPct val="70000"/>
+              <a:buFont typeface="Arial"/>
+              <a:buChar char="■"/>
               <a:defRPr lang="en-US" sz="2400" dirty="0">
                 <a:solidFill>
                   <a:schemeClr val="dk1"/>
@@ -17479,9 +17670,12 @@
               <a:spcAft>
                 <a:spcPts val="600"/>
               </a:spcAft>
-              <a:buSzPct val="115000"/>
-              <a:buFont typeface="Georgia"/>
-              <a:buChar char="▪"/>
+              <a:buClr>
+                <a:schemeClr val="accent1"/>
+              </a:buClr>
+              <a:buSzPct val="70000"/>
+              <a:buFont typeface="Arial"/>
+              <a:buChar char="■"/>
               <a:defRPr lang="en-US" sz="2400" dirty="0">
                 <a:solidFill>
                   <a:schemeClr val="dk1"/>
@@ -17498,9 +17692,12 @@
               <a:spcAft>
                 <a:spcPts val="600"/>
               </a:spcAft>
-              <a:buSzPct val="115000"/>
-              <a:buFont typeface="Georgia"/>
-              <a:buChar char="▪"/>
+              <a:buClr>
+                <a:schemeClr val="accent1"/>
+              </a:buClr>
+              <a:buSzPct val="70000"/>
+              <a:buFont typeface="Arial"/>
+              <a:buChar char="■"/>
               <a:defRPr lang="en-US" sz="2400" dirty="0">
                 <a:solidFill>
                   <a:schemeClr val="dk1"/>
@@ -17517,9 +17714,12 @@
               <a:spcAft>
                 <a:spcPts val="600"/>
               </a:spcAft>
-              <a:buSzPct val="115000"/>
-              <a:buFont typeface="Georgia"/>
-              <a:buChar char="▪"/>
+              <a:buClr>
+                <a:schemeClr val="accent1"/>
+              </a:buClr>
+              <a:buSzPct val="70000"/>
+              <a:buFont typeface="Arial"/>
+              <a:buChar char="■"/>
               <a:defRPr lang="en-US" sz="2400" dirty="0">
                 <a:solidFill>
                   <a:schemeClr val="dk1"/>
@@ -17536,9 +17736,12 @@
               <a:spcAft>
                 <a:spcPts val="600"/>
               </a:spcAft>
-              <a:buSzPct val="115000"/>
-              <a:buFont typeface="Georgia"/>
-              <a:buChar char="▪"/>
+              <a:buClr>
+                <a:schemeClr val="accent1"/>
+              </a:buClr>
+              <a:buSzPct val="70000"/>
+              <a:buFont typeface="Arial"/>
+              <a:buChar char="■"/>
               <a:defRPr lang="en-US" sz="2400" dirty="0">
                 <a:solidFill>
                   <a:schemeClr val="dk1"/>
@@ -17555,9 +17758,12 @@
               <a:spcAft>
                 <a:spcPts val="600"/>
               </a:spcAft>
-              <a:buSzPct val="115000"/>
-              <a:buFont typeface="Georgia"/>
-              <a:buChar char="▪"/>
+              <a:buClr>
+                <a:schemeClr val="accent1"/>
+              </a:buClr>
+              <a:buSzPct val="70000"/>
+              <a:buFont typeface="Arial"/>
+              <a:buChar char="■"/>
               <a:defRPr lang="en-US" sz="2400" dirty="0">
                 <a:solidFill>
                   <a:schemeClr val="dk1"/>
@@ -17576,9 +17782,12 @@
               <a:spcAft>
                 <a:spcPts val="600"/>
               </a:spcAft>
-              <a:buSzPct val="115000"/>
-              <a:buFont typeface="Georgia"/>
-              <a:buChar char="▪"/>
+              <a:buClr>
+                <a:schemeClr val="accent1"/>
+              </a:buClr>
+              <a:buSzPct val="70000"/>
+              <a:buFont typeface="Arial"/>
+              <a:buChar char="■"/>
               <a:defRPr lang="en-US" sz="2400" dirty="0">
                 <a:solidFill>
                   <a:schemeClr val="dk1"/>
@@ -18361,8 +18570,12 @@
         <a:spcBef>
           <a:spcPct val="20000"/>
         </a:spcBef>
-        <a:buFont typeface="Georgia"/>
-        <a:buChar char="▪"/>
+        <a:buClr>
+          <a:schemeClr val="accent1"/>
+        </a:buClr>
+        <a:buSzPct val="70000"/>
+        <a:buFont typeface="Arial"/>
+        <a:buChar char="■"/>
         <a:defRPr sz="3200" kern="1200">
           <a:solidFill>
             <a:schemeClr val="tx1"/>
@@ -18376,8 +18589,12 @@
         <a:spcBef>
           <a:spcPct val="20000"/>
         </a:spcBef>
-        <a:buFont typeface="Georgia"/>
-        <a:buChar char="▪"/>
+        <a:buClr>
+          <a:schemeClr val="accent1"/>
+        </a:buClr>
+        <a:buSzPct val="70000"/>
+        <a:buFont typeface="Arial"/>
+        <a:buChar char="■"/>
         <a:defRPr sz="2800" kern="1200">
           <a:solidFill>
             <a:schemeClr val="tx1"/>
@@ -18391,8 +18608,12 @@
         <a:spcBef>
           <a:spcPct val="20000"/>
         </a:spcBef>
-        <a:buFont typeface="Georgia"/>
-        <a:buChar char="▪"/>
+        <a:buClr>
+          <a:schemeClr val="accent1"/>
+        </a:buClr>
+        <a:buSzPct val="70000"/>
+        <a:buFont typeface="Arial"/>
+        <a:buChar char="■"/>
         <a:defRPr sz="2400" kern="1200">
           <a:solidFill>
             <a:schemeClr val="tx1"/>
@@ -18406,8 +18627,12 @@
         <a:spcBef>
           <a:spcPct val="20000"/>
         </a:spcBef>
-        <a:buFont typeface="Georgia"/>
-        <a:buChar char="▪"/>
+        <a:buClr>
+          <a:schemeClr val="accent1"/>
+        </a:buClr>
+        <a:buSzPct val="70000"/>
+        <a:buFont typeface="Arial"/>
+        <a:buChar char="■"/>
         <a:defRPr sz="2000" kern="1200">
           <a:solidFill>
             <a:schemeClr val="tx1"/>
@@ -18421,8 +18646,12 @@
         <a:spcBef>
           <a:spcPct val="20000"/>
         </a:spcBef>
-        <a:buFont typeface="Georgia"/>
-        <a:buChar char="▪"/>
+        <a:buClr>
+          <a:schemeClr val="accent1"/>
+        </a:buClr>
+        <a:buSzPct val="70000"/>
+        <a:buFont typeface="Arial"/>
+        <a:buChar char="■"/>
         <a:defRPr sz="2000" kern="1200">
           <a:solidFill>
             <a:schemeClr val="tx1"/>
@@ -18436,8 +18665,12 @@
         <a:spcBef>
           <a:spcPct val="20000"/>
         </a:spcBef>
-        <a:buFont typeface="Georgia"/>
-        <a:buChar char="▪"/>
+        <a:buClr>
+          <a:schemeClr val="accent1"/>
+        </a:buClr>
+        <a:buSzPct val="70000"/>
+        <a:buFont typeface="Arial"/>
+        <a:buChar char="■"/>
         <a:defRPr sz="2000" kern="1200">
           <a:solidFill>
             <a:schemeClr val="tx1"/>
@@ -18451,8 +18684,12 @@
         <a:spcBef>
           <a:spcPct val="20000"/>
         </a:spcBef>
-        <a:buFont typeface="Georgia"/>
-        <a:buChar char="▪"/>
+        <a:buClr>
+          <a:schemeClr val="accent1"/>
+        </a:buClr>
+        <a:buSzPct val="70000"/>
+        <a:buFont typeface="Arial"/>
+        <a:buChar char="■"/>
         <a:defRPr sz="2000" kern="1200">
           <a:solidFill>
             <a:schemeClr val="tx1"/>
@@ -18466,8 +18703,12 @@
         <a:spcBef>
           <a:spcPct val="20000"/>
         </a:spcBef>
-        <a:buFont typeface="Georgia"/>
-        <a:buChar char="▪"/>
+        <a:buClr>
+          <a:schemeClr val="accent1"/>
+        </a:buClr>
+        <a:buSzPct val="70000"/>
+        <a:buFont typeface="Arial"/>
+        <a:buChar char="■"/>
         <a:defRPr sz="2000" kern="1200">
           <a:solidFill>
             <a:schemeClr val="tx1"/>
@@ -18481,8 +18722,12 @@
         <a:spcBef>
           <a:spcPct val="20000"/>
         </a:spcBef>
-        <a:buFont typeface="Georgia"/>
-        <a:buChar char="▪"/>
+        <a:buClr>
+          <a:schemeClr val="accent1"/>
+        </a:buClr>
+        <a:buSzPct val="70000"/>
+        <a:buFont typeface="Arial"/>
+        <a:buChar char="■"/>
         <a:defRPr sz="2000" kern="1200">
           <a:solidFill>
             <a:schemeClr val="tx1"/>
@@ -20469,9 +20714,12 @@
               <a:spcAft>
                 <a:spcPts val="600"/>
               </a:spcAft>
-              <a:buSzPct val="115000"/>
-              <a:buFont typeface="Georgia"/>
-              <a:buChar char="▪"/>
+              <a:buClr>
+                <a:schemeClr val="accent1"/>
+              </a:buClr>
+              <a:buSzPct val="70000"/>
+              <a:buFont typeface="Arial"/>
+              <a:buChar char="■"/>
               <a:defRPr lang="en-US" sz="2025" dirty="0">
                 <a:solidFill>
                   <a:schemeClr val="dk1"/>
@@ -20488,9 +20736,12 @@
               <a:spcAft>
                 <a:spcPts val="600"/>
               </a:spcAft>
-              <a:buSzPct val="115000"/>
-              <a:buFont typeface="Georgia"/>
-              <a:buChar char="▪"/>
+              <a:buClr>
+                <a:schemeClr val="accent1"/>
+              </a:buClr>
+              <a:buSzPct val="70000"/>
+              <a:buFont typeface="Arial"/>
+              <a:buChar char="■"/>
               <a:defRPr lang="en-US" sz="2025" dirty="0">
                 <a:solidFill>
                   <a:schemeClr val="dk1"/>
@@ -20507,9 +20758,12 @@
               <a:spcAft>
                 <a:spcPts val="600"/>
               </a:spcAft>
-              <a:buSzPct val="115000"/>
-              <a:buFont typeface="Georgia"/>
-              <a:buChar char="▪"/>
+              <a:buClr>
+                <a:schemeClr val="accent1"/>
+              </a:buClr>
+              <a:buSzPct val="70000"/>
+              <a:buFont typeface="Arial"/>
+              <a:buChar char="■"/>
               <a:defRPr lang="en-US" sz="2025" dirty="0">
                 <a:solidFill>
                   <a:schemeClr val="dk1"/>
@@ -20526,9 +20780,12 @@
               <a:spcAft>
                 <a:spcPts val="600"/>
               </a:spcAft>
-              <a:buSzPct val="115000"/>
-              <a:buFont typeface="Georgia"/>
-              <a:buChar char="▪"/>
+              <a:buClr>
+                <a:schemeClr val="accent1"/>
+              </a:buClr>
+              <a:buSzPct val="70000"/>
+              <a:buFont typeface="Arial"/>
+              <a:buChar char="■"/>
               <a:defRPr lang="en-US" sz="2025" dirty="0">
                 <a:solidFill>
                   <a:schemeClr val="dk1"/>
@@ -20545,9 +20802,12 @@
               <a:spcAft>
                 <a:spcPts val="600"/>
               </a:spcAft>
-              <a:buSzPct val="115000"/>
-              <a:buFont typeface="Georgia"/>
-              <a:buChar char="▪"/>
+              <a:buClr>
+                <a:schemeClr val="accent1"/>
+              </a:buClr>
+              <a:buSzPct val="70000"/>
+              <a:buFont typeface="Arial"/>
+              <a:buChar char="■"/>
               <a:defRPr lang="en-US" sz="2025" dirty="0">
                 <a:solidFill>
                   <a:schemeClr val="dk1"/>
@@ -20564,9 +20824,12 @@
               <a:spcAft>
                 <a:spcPts val="600"/>
               </a:spcAft>
-              <a:buSzPct val="115000"/>
-              <a:buFont typeface="Georgia"/>
-              <a:buChar char="▪"/>
+              <a:buClr>
+                <a:schemeClr val="accent1"/>
+              </a:buClr>
+              <a:buSzPct val="70000"/>
+              <a:buFont typeface="Arial"/>
+              <a:buChar char="■"/>
               <a:defRPr lang="en-US" sz="2025" dirty="0">
                 <a:solidFill>
                   <a:schemeClr val="dk1"/>
@@ -20583,9 +20846,12 @@
               <a:spcAft>
                 <a:spcPts val="600"/>
               </a:spcAft>
-              <a:buSzPct val="115000"/>
-              <a:buFont typeface="Georgia"/>
-              <a:buChar char="▪"/>
+              <a:buClr>
+                <a:schemeClr val="accent1"/>
+              </a:buClr>
+              <a:buSzPct val="70000"/>
+              <a:buFont typeface="Arial"/>
+              <a:buChar char="■"/>
               <a:defRPr lang="en-US" sz="2025" dirty="0">
                 <a:solidFill>
                   <a:schemeClr val="dk1"/>
@@ -20602,9 +20868,12 @@
               <a:spcAft>
                 <a:spcPts val="600"/>
               </a:spcAft>
-              <a:buSzPct val="115000"/>
-              <a:buFont typeface="Georgia"/>
-              <a:buChar char="▪"/>
+              <a:buClr>
+                <a:schemeClr val="accent1"/>
+              </a:buClr>
+              <a:buSzPct val="70000"/>
+              <a:buFont typeface="Arial"/>
+              <a:buChar char="■"/>
               <a:defRPr lang="en-US" sz="2025" dirty="0">
                 <a:solidFill>
                   <a:schemeClr val="dk1"/>
@@ -20621,9 +20890,12 @@
               <a:spcAft>
                 <a:spcPts val="600"/>
               </a:spcAft>
-              <a:buSzPct val="115000"/>
-              <a:buFont typeface="Georgia"/>
-              <a:buChar char="▪"/>
+              <a:buClr>
+                <a:schemeClr val="accent1"/>
+              </a:buClr>
+              <a:buSzPct val="70000"/>
+              <a:buFont typeface="Arial"/>
+              <a:buChar char="■"/>
               <a:defRPr lang="en-US" sz="2025" dirty="0">
                 <a:solidFill>
                   <a:schemeClr val="dk1"/>
@@ -20640,9 +20912,12 @@
               <a:spcAft>
                 <a:spcPts val="600"/>
               </a:spcAft>
-              <a:buSzPct val="115000"/>
-              <a:buFont typeface="Georgia"/>
-              <a:buChar char="▪"/>
+              <a:buClr>
+                <a:schemeClr val="accent1"/>
+              </a:buClr>
+              <a:buSzPct val="70000"/>
+              <a:buFont typeface="Arial"/>
+              <a:buChar char="■"/>
               <a:defRPr lang="en-US" sz="2025" dirty="0">
                 <a:solidFill>
                   <a:schemeClr val="dk1"/>
@@ -20661,9 +20936,12 @@
               <a:spcAft>
                 <a:spcPts val="600"/>
               </a:spcAft>
-              <a:buSzPct val="115000"/>
-              <a:buFont typeface="Georgia"/>
-              <a:buChar char="▪"/>
+              <a:buClr>
+                <a:schemeClr val="accent1"/>
+              </a:buClr>
+              <a:buSzPct val="70000"/>
+              <a:buFont typeface="Arial"/>
+              <a:buChar char="■"/>
               <a:defRPr lang="en-US" sz="2025" dirty="0">
                 <a:solidFill>
                   <a:schemeClr val="dk1"/>
@@ -20701,9 +20979,12 @@
               <a:spcAft>
                 <a:spcPts val="600"/>
               </a:spcAft>
-              <a:buSzPct val="115000"/>
-              <a:buFont typeface="Georgia"/>
-              <a:buChar char="▪"/>
+              <a:buClr>
+                <a:schemeClr val="accent1"/>
+              </a:buClr>
+              <a:buSzPct val="70000"/>
+              <a:buFont typeface="Arial"/>
+              <a:buChar char="■"/>
               <a:defRPr lang="en-US" sz="2025" dirty="0">
                 <a:solidFill>
                   <a:schemeClr val="dk1"/>
@@ -20741,9 +21022,12 @@
               <a:spcAft>
                 <a:spcPts val="600"/>
               </a:spcAft>
-              <a:buSzPct val="115000"/>
-              <a:buFont typeface="Georgia"/>
-              <a:buChar char="▪"/>
+              <a:buClr>
+                <a:schemeClr val="accent1"/>
+              </a:buClr>
+              <a:buSzPct val="70000"/>
+              <a:buFont typeface="Arial"/>
+              <a:buChar char="■"/>
               <a:defRPr lang="en-US" sz="2025" dirty="0">
                 <a:solidFill>
                   <a:schemeClr val="dk1"/>
@@ -20781,9 +21065,12 @@
               <a:spcAft>
                 <a:spcPts val="600"/>
               </a:spcAft>
-              <a:buSzPct val="115000"/>
-              <a:buFont typeface="Georgia"/>
-              <a:buChar char="▪"/>
+              <a:buClr>
+                <a:schemeClr val="accent1"/>
+              </a:buClr>
+              <a:buSzPct val="70000"/>
+              <a:buFont typeface="Arial"/>
+              <a:buChar char="■"/>
               <a:defRPr lang="en-US" sz="2025" dirty="0">
                 <a:solidFill>
                   <a:schemeClr val="dk1"/>
@@ -20821,9 +21108,12 @@
               <a:spcAft>
                 <a:spcPts val="600"/>
               </a:spcAft>
-              <a:buSzPct val="115000"/>
-              <a:buFont typeface="Georgia"/>
-              <a:buChar char="▪"/>
+              <a:buClr>
+                <a:schemeClr val="accent1"/>
+              </a:buClr>
+              <a:buSzPct val="70000"/>
+              <a:buFont typeface="Arial"/>
+              <a:buChar char="■"/>
               <a:defRPr lang="en-US" sz="2025" dirty="0">
                 <a:solidFill>
                   <a:schemeClr val="dk1"/>
@@ -21492,9 +21782,12 @@
               <a:spcAft>
                 <a:spcPts val="600"/>
               </a:spcAft>
-              <a:buSzPct val="115000"/>
-              <a:buFont typeface="Georgia"/>
-              <a:buChar char="▪"/>
+              <a:buClr>
+                <a:schemeClr val="accent1"/>
+              </a:buClr>
+              <a:buSzPct val="70000"/>
+              <a:buFont typeface="Arial"/>
+              <a:buChar char="■"/>
               <a:defRPr lang="en-US" sz="2400" dirty="0">
                 <a:solidFill>
                   <a:schemeClr val="dk1"/>
@@ -21511,9 +21804,12 @@
               <a:spcAft>
                 <a:spcPts val="600"/>
               </a:spcAft>
-              <a:buSzPct val="115000"/>
-              <a:buFont typeface="Georgia"/>
-              <a:buChar char="▪"/>
+              <a:buClr>
+                <a:schemeClr val="accent1"/>
+              </a:buClr>
+              <a:buSzPct val="70000"/>
+              <a:buFont typeface="Arial"/>
+              <a:buChar char="■"/>
               <a:defRPr lang="en-US" sz="2400" dirty="0">
                 <a:solidFill>
                   <a:schemeClr val="dk1"/>
@@ -21530,9 +21826,12 @@
               <a:spcAft>
                 <a:spcPts val="600"/>
               </a:spcAft>
-              <a:buSzPct val="115000"/>
-              <a:buFont typeface="Georgia"/>
-              <a:buChar char="▪"/>
+              <a:buClr>
+                <a:schemeClr val="accent1"/>
+              </a:buClr>
+              <a:buSzPct val="70000"/>
+              <a:buFont typeface="Arial"/>
+              <a:buChar char="■"/>
               <a:defRPr lang="en-US" sz="2400" dirty="0">
                 <a:solidFill>
                   <a:schemeClr val="dk1"/>
@@ -21549,9 +21848,12 @@
               <a:spcAft>
                 <a:spcPts val="600"/>
               </a:spcAft>
-              <a:buSzPct val="115000"/>
-              <a:buFont typeface="Georgia"/>
-              <a:buChar char="▪"/>
+              <a:buClr>
+                <a:schemeClr val="accent1"/>
+              </a:buClr>
+              <a:buSzPct val="70000"/>
+              <a:buFont typeface="Arial"/>
+              <a:buChar char="■"/>
               <a:defRPr lang="en-US" sz="2400" dirty="0">
                 <a:solidFill>
                   <a:schemeClr val="dk1"/>
@@ -21568,9 +21870,12 @@
               <a:spcAft>
                 <a:spcPts val="600"/>
               </a:spcAft>
-              <a:buSzPct val="115000"/>
-              <a:buFont typeface="Georgia"/>
-              <a:buChar char="▪"/>
+              <a:buClr>
+                <a:schemeClr val="accent1"/>
+              </a:buClr>
+              <a:buSzPct val="70000"/>
+              <a:buFont typeface="Arial"/>
+              <a:buChar char="■"/>
               <a:defRPr lang="en-US" sz="2400" dirty="0">
                 <a:solidFill>
                   <a:schemeClr val="dk1"/>
@@ -21587,9 +21892,12 @@
               <a:spcAft>
                 <a:spcPts val="600"/>
               </a:spcAft>
-              <a:buSzPct val="115000"/>
-              <a:buFont typeface="Georgia"/>
-              <a:buChar char="▪"/>
+              <a:buClr>
+                <a:schemeClr val="accent1"/>
+              </a:buClr>
+              <a:buSzPct val="70000"/>
+              <a:buFont typeface="Arial"/>
+              <a:buChar char="■"/>
               <a:defRPr lang="en-US" sz="2400" dirty="0">
                 <a:solidFill>
                   <a:schemeClr val="dk1"/>
@@ -21606,9 +21914,12 @@
               <a:spcAft>
                 <a:spcPts val="600"/>
               </a:spcAft>
-              <a:buSzPct val="115000"/>
-              <a:buFont typeface="Georgia"/>
-              <a:buChar char="▪"/>
+              <a:buClr>
+                <a:schemeClr val="accent1"/>
+              </a:buClr>
+              <a:buSzPct val="70000"/>
+              <a:buFont typeface="Arial"/>
+              <a:buChar char="■"/>
               <a:defRPr lang="en-US" sz="2400" dirty="0">
                 <a:solidFill>
                   <a:schemeClr val="dk1"/>
@@ -21625,9 +21936,12 @@
               <a:spcAft>
                 <a:spcPts val="600"/>
               </a:spcAft>
-              <a:buSzPct val="115000"/>
-              <a:buFont typeface="Georgia"/>
-              <a:buChar char="▪"/>
+              <a:buClr>
+                <a:schemeClr val="accent1"/>
+              </a:buClr>
+              <a:buSzPct val="70000"/>
+              <a:buFont typeface="Arial"/>
+              <a:buChar char="■"/>
               <a:defRPr lang="en-US" sz="2400" dirty="0">
                 <a:solidFill>
                   <a:schemeClr val="dk1"/>
@@ -21644,9 +21958,12 @@
               <a:spcAft>
                 <a:spcPts val="600"/>
               </a:spcAft>
-              <a:buSzPct val="115000"/>
-              <a:buFont typeface="Georgia"/>
-              <a:buChar char="▪"/>
+              <a:buClr>
+                <a:schemeClr val="accent1"/>
+              </a:buClr>
+              <a:buSzPct val="70000"/>
+              <a:buFont typeface="Arial"/>
+              <a:buChar char="■"/>
               <a:defRPr lang="en-US" sz="2400" dirty="0">
                 <a:solidFill>
                   <a:schemeClr val="dk1"/>
@@ -21663,9 +21980,12 @@
               <a:spcAft>
                 <a:spcPts val="600"/>
               </a:spcAft>
-              <a:buSzPct val="115000"/>
-              <a:buFont typeface="Georgia"/>
-              <a:buChar char="▪"/>
+              <a:buClr>
+                <a:schemeClr val="accent1"/>
+              </a:buClr>
+              <a:buSzPct val="70000"/>
+              <a:buFont typeface="Arial"/>
+              <a:buChar char="■"/>
               <a:defRPr lang="en-US" sz="2400" dirty="0">
                 <a:solidFill>
                   <a:schemeClr val="dk1"/>
@@ -21684,9 +22004,12 @@
               <a:spcAft>
                 <a:spcPts val="600"/>
               </a:spcAft>
-              <a:buSzPct val="115000"/>
-              <a:buFont typeface="Georgia"/>
-              <a:buChar char="▪"/>
+              <a:buClr>
+                <a:schemeClr val="accent1"/>
+              </a:buClr>
+              <a:buSzPct val="70000"/>
+              <a:buFont typeface="Arial"/>
+              <a:buChar char="■"/>
               <a:defRPr lang="en-US" sz="2400" dirty="0">
                 <a:solidFill>
                   <a:schemeClr val="dk1"/>
@@ -21724,9 +22047,12 @@
               <a:spcAft>
                 <a:spcPts val="600"/>
               </a:spcAft>
-              <a:buSzPct val="115000"/>
-              <a:buFont typeface="Georgia"/>
-              <a:buChar char="▪"/>
+              <a:buClr>
+                <a:schemeClr val="accent1"/>
+              </a:buClr>
+              <a:buSzPct val="70000"/>
+              <a:buFont typeface="Arial"/>
+              <a:buChar char="■"/>
               <a:defRPr lang="en-US" sz="2400" dirty="0">
                 <a:solidFill>
                   <a:schemeClr val="dk1"/>
@@ -21764,9 +22090,12 @@
               <a:spcAft>
                 <a:spcPts val="600"/>
               </a:spcAft>
-              <a:buSzPct val="115000"/>
-              <a:buFont typeface="Georgia"/>
-              <a:buChar char="▪"/>
+              <a:buClr>
+                <a:schemeClr val="accent1"/>
+              </a:buClr>
+              <a:buSzPct val="70000"/>
+              <a:buFont typeface="Arial"/>
+              <a:buChar char="■"/>
               <a:defRPr lang="en-US" sz="2400" dirty="0">
                 <a:solidFill>
                   <a:schemeClr val="dk1"/>
@@ -21804,9 +22133,12 @@
               <a:spcAft>
                 <a:spcPts val="600"/>
               </a:spcAft>
-              <a:buSzPct val="115000"/>
-              <a:buFont typeface="Georgia"/>
-              <a:buChar char="▪"/>
+              <a:buClr>
+                <a:schemeClr val="accent1"/>
+              </a:buClr>
+              <a:buSzPct val="70000"/>
+              <a:buFont typeface="Arial"/>
+              <a:buChar char="■"/>
               <a:defRPr lang="en-US" sz="2400" dirty="0">
                 <a:solidFill>
                   <a:schemeClr val="dk1"/>
@@ -24711,9 +25043,10 @@
               <a:spcAft>
                 <a:spcPts val="600"/>
               </a:spcAft>
-              <a:buSzPct val="135000"/>
-              <a:buFont typeface="Georgia"/>
-              <a:buChar char="▪"/>
+              <a:buClrTx/>
+              <a:buSzPct val="70000"/>
+              <a:buFont typeface="Arial"/>
+              <a:buChar char="■"/>
               <a:defRPr lang="en-US" sz="2600" dirty="0">
                 <a:solidFill>
                   <a:schemeClr val="bg1"/>
@@ -24729,9 +25062,10 @@
               <a:spcAft>
                 <a:spcPts val="600"/>
               </a:spcAft>
-              <a:buSzPct val="135000"/>
-              <a:buFont typeface="Georgia"/>
-              <a:buChar char="▪"/>
+              <a:buClrTx/>
+              <a:buSzPct val="70000"/>
+              <a:buFont typeface="Arial"/>
+              <a:buChar char="■"/>
               <a:defRPr lang="en-US" sz="2600" dirty="0">
                 <a:solidFill>
                   <a:schemeClr val="bg1"/>
@@ -24747,9 +25081,10 @@
               <a:spcAft>
                 <a:spcPts val="600"/>
               </a:spcAft>
-              <a:buSzPct val="135000"/>
-              <a:buFont typeface="Georgia"/>
-              <a:buChar char="▪"/>
+              <a:buClrTx/>
+              <a:buSzPct val="70000"/>
+              <a:buFont typeface="Arial"/>
+              <a:buChar char="■"/>
               <a:defRPr lang="en-US" sz="2600" dirty="0">
                 <a:solidFill>
                   <a:schemeClr val="bg1"/>
@@ -24765,9 +25100,10 @@
               <a:spcAft>
                 <a:spcPts val="600"/>
               </a:spcAft>
-              <a:buSzPct val="135000"/>
-              <a:buFont typeface="Georgia"/>
-              <a:buChar char="▪"/>
+              <a:buClrTx/>
+              <a:buSzPct val="70000"/>
+              <a:buFont typeface="Arial"/>
+              <a:buChar char="■"/>
               <a:defRPr lang="en-US" sz="2600" dirty="0">
                 <a:solidFill>
                   <a:schemeClr val="bg1"/>
@@ -24783,9 +25119,10 @@
               <a:spcAft>
                 <a:spcPts val="600"/>
               </a:spcAft>
-              <a:buSzPct val="135000"/>
-              <a:buFont typeface="Georgia"/>
-              <a:buChar char="▪"/>
+              <a:buClrTx/>
+              <a:buSzPct val="70000"/>
+              <a:buFont typeface="Arial"/>
+              <a:buChar char="■"/>
               <a:defRPr lang="en-US" sz="2600" dirty="0">
                 <a:solidFill>
                   <a:schemeClr val="bg1"/>
@@ -24801,9 +25138,10 @@
               <a:spcAft>
                 <a:spcPts val="600"/>
               </a:spcAft>
-              <a:buSzPct val="135000"/>
-              <a:buFont typeface="Georgia"/>
-              <a:buChar char="▪"/>
+              <a:buClrTx/>
+              <a:buSzPct val="70000"/>
+              <a:buFont typeface="Arial"/>
+              <a:buChar char="■"/>
               <a:defRPr lang="en-US" sz="2600" dirty="0">
                 <a:solidFill>
                   <a:schemeClr val="bg1"/>
@@ -24819,9 +25157,10 @@
               <a:spcAft>
                 <a:spcPts val="600"/>
               </a:spcAft>
-              <a:buSzPct val="135000"/>
-              <a:buFont typeface="Georgia"/>
-              <a:buChar char="▪"/>
+              <a:buClrTx/>
+              <a:buSzPct val="70000"/>
+              <a:buFont typeface="Arial"/>
+              <a:buChar char="■"/>
               <a:defRPr lang="en-US" sz="2600" dirty="0">
                 <a:solidFill>
                   <a:schemeClr val="bg1"/>
@@ -24837,9 +25176,10 @@
               <a:spcAft>
                 <a:spcPts val="600"/>
               </a:spcAft>
-              <a:buSzPct val="135000"/>
-              <a:buFont typeface="Georgia"/>
-              <a:buChar char="▪"/>
+              <a:buClrTx/>
+              <a:buSzPct val="70000"/>
+              <a:buFont typeface="Arial"/>
+              <a:buChar char="■"/>
               <a:defRPr lang="en-US" sz="2600" dirty="0">
                 <a:solidFill>
                   <a:schemeClr val="bg1"/>
@@ -24855,9 +25195,10 @@
               <a:spcAft>
                 <a:spcPts val="600"/>
               </a:spcAft>
-              <a:buSzPct val="135000"/>
-              <a:buFont typeface="Georgia"/>
-              <a:buChar char="▪"/>
+              <a:buClrTx/>
+              <a:buSzPct val="70000"/>
+              <a:buFont typeface="Arial"/>
+              <a:buChar char="■"/>
               <a:defRPr lang="en-US" sz="2600" dirty="0">
                 <a:solidFill>
                   <a:schemeClr val="bg1"/>
@@ -24873,9 +25214,10 @@
               <a:spcAft>
                 <a:spcPts val="600"/>
               </a:spcAft>
-              <a:buSzPct val="135000"/>
-              <a:buFont typeface="Georgia"/>
-              <a:buChar char="▪"/>
+              <a:buClrTx/>
+              <a:buSzPct val="70000"/>
+              <a:buFont typeface="Arial"/>
+              <a:buChar char="■"/>
               <a:defRPr lang="en-US" sz="2600" dirty="0">
                 <a:solidFill>
                   <a:schemeClr val="bg1"/>
@@ -24893,9 +25235,10 @@
               <a:spcAft>
                 <a:spcPts val="600"/>
               </a:spcAft>
-              <a:buSzPct val="135000"/>
-              <a:buFont typeface="Georgia"/>
-              <a:buChar char="▪"/>
+              <a:buClrTx/>
+              <a:buSzPct val="70000"/>
+              <a:buFont typeface="Arial"/>
+              <a:buChar char="■"/>
               <a:defRPr lang="en-US" sz="2600" dirty="0">
                 <a:solidFill>
                   <a:schemeClr val="bg1"/>
@@ -24930,9 +25273,10 @@
               <a:spcAft>
                 <a:spcPts val="600"/>
               </a:spcAft>
-              <a:buSzPct val="135000"/>
-              <a:buFont typeface="Georgia"/>
-              <a:buChar char="▪"/>
+              <a:buClrTx/>
+              <a:buSzPct val="70000"/>
+              <a:buFont typeface="Arial"/>
+              <a:buChar char="■"/>
               <a:defRPr lang="en-US" sz="2600" dirty="0">
                 <a:solidFill>
                   <a:schemeClr val="bg1"/>
@@ -24967,9 +25311,10 @@
               <a:spcAft>
                 <a:spcPts val="600"/>
               </a:spcAft>
-              <a:buSzPct val="135000"/>
-              <a:buFont typeface="Georgia"/>
-              <a:buChar char="▪"/>
+              <a:buClrTx/>
+              <a:buSzPct val="70000"/>
+              <a:buFont typeface="Arial"/>
+              <a:buChar char="■"/>
               <a:defRPr lang="en-US" sz="2600" dirty="0">
                 <a:solidFill>
                   <a:schemeClr val="bg1"/>
@@ -25004,9 +25349,10 @@
               <a:spcAft>
                 <a:spcPts val="600"/>
               </a:spcAft>
-              <a:buSzPct val="135000"/>
-              <a:buFont typeface="Georgia"/>
-              <a:buChar char="▪"/>
+              <a:buClrTx/>
+              <a:buSzPct val="70000"/>
+              <a:buFont typeface="Arial"/>
+              <a:buChar char="■"/>
               <a:defRPr lang="en-US" sz="2600" dirty="0">
                 <a:solidFill>
                   <a:schemeClr val="bg1"/>
@@ -25272,9 +25618,12 @@
               <a:spcAft>
                 <a:spcPts val="600"/>
               </a:spcAft>
-              <a:buSzPct val="135000"/>
-              <a:buFont typeface="Georgia"/>
-              <a:buChar char="▪"/>
+              <a:buClr>
+                <a:schemeClr val="accent1"/>
+              </a:buClr>
+              <a:buSzPct val="70000"/>
+              <a:buFont typeface="Arial"/>
+              <a:buChar char="■"/>
               <a:defRPr lang="en-US" sz="2600" dirty="0">
                 <a:solidFill>
                   <a:schemeClr val="dk1"/>
@@ -25291,9 +25640,12 @@
               <a:spcAft>
                 <a:spcPts val="600"/>
               </a:spcAft>
-              <a:buSzPct val="135000"/>
-              <a:buFont typeface="Georgia"/>
-              <a:buChar char="▪"/>
+              <a:buClr>
+                <a:schemeClr val="accent1"/>
+              </a:buClr>
+              <a:buSzPct val="70000"/>
+              <a:buFont typeface="Arial"/>
+              <a:buChar char="■"/>
               <a:defRPr lang="en-US" sz="2600" dirty="0">
                 <a:solidFill>
                   <a:schemeClr val="dk1"/>
@@ -25310,9 +25662,12 @@
               <a:spcAft>
                 <a:spcPts val="600"/>
               </a:spcAft>
-              <a:buSzPct val="135000"/>
-              <a:buFont typeface="Georgia"/>
-              <a:buChar char="▪"/>
+              <a:buClr>
+                <a:schemeClr val="accent1"/>
+              </a:buClr>
+              <a:buSzPct val="70000"/>
+              <a:buFont typeface="Arial"/>
+              <a:buChar char="■"/>
               <a:defRPr lang="en-US" sz="2600" dirty="0">
                 <a:solidFill>
                   <a:schemeClr val="dk1"/>
@@ -25329,9 +25684,12 @@
               <a:spcAft>
                 <a:spcPts val="600"/>
               </a:spcAft>
-              <a:buSzPct val="135000"/>
-              <a:buFont typeface="Georgia"/>
-              <a:buChar char="▪"/>
+              <a:buClr>
+                <a:schemeClr val="accent1"/>
+              </a:buClr>
+              <a:buSzPct val="70000"/>
+              <a:buFont typeface="Arial"/>
+              <a:buChar char="■"/>
               <a:defRPr lang="en-US" sz="2600" dirty="0">
                 <a:solidFill>
                   <a:schemeClr val="dk1"/>
@@ -25348,9 +25706,12 @@
               <a:spcAft>
                 <a:spcPts val="600"/>
               </a:spcAft>
-              <a:buSzPct val="135000"/>
-              <a:buFont typeface="Georgia"/>
-              <a:buChar char="▪"/>
+              <a:buClr>
+                <a:schemeClr val="accent1"/>
+              </a:buClr>
+              <a:buSzPct val="70000"/>
+              <a:buFont typeface="Arial"/>
+              <a:buChar char="■"/>
               <a:defRPr lang="en-US" sz="2600" dirty="0">
                 <a:solidFill>
                   <a:schemeClr val="dk1"/>
@@ -25367,9 +25728,12 @@
               <a:spcAft>
                 <a:spcPts val="600"/>
               </a:spcAft>
-              <a:buSzPct val="135000"/>
-              <a:buFont typeface="Georgia"/>
-              <a:buChar char="▪"/>
+              <a:buClr>
+                <a:schemeClr val="accent1"/>
+              </a:buClr>
+              <a:buSzPct val="70000"/>
+              <a:buFont typeface="Arial"/>
+              <a:buChar char="■"/>
               <a:defRPr lang="en-US" sz="2600" dirty="0">
                 <a:solidFill>
                   <a:schemeClr val="dk1"/>
@@ -25386,9 +25750,12 @@
               <a:spcAft>
                 <a:spcPts val="600"/>
               </a:spcAft>
-              <a:buSzPct val="135000"/>
-              <a:buFont typeface="Georgia"/>
-              <a:buChar char="▪"/>
+              <a:buClr>
+                <a:schemeClr val="accent1"/>
+              </a:buClr>
+              <a:buSzPct val="70000"/>
+              <a:buFont typeface="Arial"/>
+              <a:buChar char="■"/>
               <a:defRPr lang="en-US" sz="2600" dirty="0">
                 <a:solidFill>
                   <a:schemeClr val="dk1"/>
@@ -25405,9 +25772,12 @@
               <a:spcAft>
                 <a:spcPts val="600"/>
               </a:spcAft>
-              <a:buSzPct val="135000"/>
-              <a:buFont typeface="Georgia"/>
-              <a:buChar char="▪"/>
+              <a:buClr>
+                <a:schemeClr val="accent1"/>
+              </a:buClr>
+              <a:buSzPct val="70000"/>
+              <a:buFont typeface="Arial"/>
+              <a:buChar char="■"/>
               <a:defRPr lang="en-US" sz="2600" dirty="0">
                 <a:solidFill>
                   <a:schemeClr val="dk1"/>
@@ -25424,9 +25794,12 @@
               <a:spcAft>
                 <a:spcPts val="600"/>
               </a:spcAft>
-              <a:buSzPct val="135000"/>
-              <a:buFont typeface="Georgia"/>
-              <a:buChar char="▪"/>
+              <a:buClr>
+                <a:schemeClr val="accent1"/>
+              </a:buClr>
+              <a:buSzPct val="70000"/>
+              <a:buFont typeface="Arial"/>
+              <a:buChar char="■"/>
               <a:defRPr lang="en-US" sz="2600" dirty="0">
                 <a:solidFill>
                   <a:schemeClr val="dk1"/>
@@ -25443,9 +25816,12 @@
               <a:spcAft>
                 <a:spcPts val="600"/>
               </a:spcAft>
-              <a:buSzPct val="135000"/>
-              <a:buFont typeface="Georgia"/>
-              <a:buChar char="▪"/>
+              <a:buClr>
+                <a:schemeClr val="accent1"/>
+              </a:buClr>
+              <a:buSzPct val="70000"/>
+              <a:buFont typeface="Arial"/>
+              <a:buChar char="■"/>
               <a:defRPr lang="en-US" sz="2600" dirty="0">
                 <a:solidFill>
                   <a:schemeClr val="dk1"/>
@@ -25464,9 +25840,12 @@
               <a:spcAft>
                 <a:spcPts val="600"/>
               </a:spcAft>
-              <a:buSzPct val="135000"/>
-              <a:buFont typeface="Georgia"/>
-              <a:buChar char="▪"/>
+              <a:buClr>
+                <a:schemeClr val="accent1"/>
+              </a:buClr>
+              <a:buSzPct val="70000"/>
+              <a:buFont typeface="Arial"/>
+              <a:buChar char="■"/>
               <a:defRPr lang="en-US" sz="2600" dirty="0">
                 <a:solidFill>
                   <a:schemeClr val="dk1"/>
@@ -25504,9 +25883,12 @@
               <a:spcAft>
                 <a:spcPts val="600"/>
               </a:spcAft>
-              <a:buSzPct val="135000"/>
-              <a:buFont typeface="Georgia"/>
-              <a:buChar char="▪"/>
+              <a:buClr>
+                <a:schemeClr val="accent1"/>
+              </a:buClr>
+              <a:buSzPct val="70000"/>
+              <a:buFont typeface="Arial"/>
+              <a:buChar char="■"/>
               <a:defRPr lang="en-US" sz="2600" dirty="0">
                 <a:solidFill>
                   <a:schemeClr val="dk1"/>
@@ -25544,9 +25926,12 @@
               <a:spcAft>
                 <a:spcPts val="600"/>
               </a:spcAft>
-              <a:buSzPct val="135000"/>
-              <a:buFont typeface="Georgia"/>
-              <a:buChar char="▪"/>
+              <a:buClr>
+                <a:schemeClr val="accent1"/>
+              </a:buClr>
+              <a:buSzPct val="70000"/>
+              <a:buFont typeface="Arial"/>
+              <a:buChar char="■"/>
               <a:defRPr lang="en-US" sz="2600" dirty="0">
                 <a:solidFill>
                   <a:schemeClr val="dk1"/>
@@ -25584,9 +25969,12 @@
               <a:spcAft>
                 <a:spcPts val="600"/>
               </a:spcAft>
-              <a:buSzPct val="135000"/>
-              <a:buFont typeface="Georgia"/>
-              <a:buChar char="▪"/>
+              <a:buClr>
+                <a:schemeClr val="accent1"/>
+              </a:buClr>
+              <a:buSzPct val="70000"/>
+              <a:buFont typeface="Arial"/>
+              <a:buChar char="■"/>
               <a:defRPr lang="en-US" sz="2600" dirty="0">
                 <a:solidFill>
                   <a:schemeClr val="dk1"/>
@@ -30931,9 +31319,12 @@
               <a:spcAft>
                 <a:spcPts val="600"/>
               </a:spcAft>
-              <a:buSzPct val="115000"/>
-              <a:buFont typeface="Georgia"/>
-              <a:buChar char="▪"/>
+              <a:buClr>
+                <a:schemeClr val="accent1"/>
+              </a:buClr>
+              <a:buSzPct val="70000"/>
+              <a:buFont typeface="Arial"/>
+              <a:buChar char="■"/>
               <a:defRPr lang="en-US" sz="2400" dirty="0">
                 <a:solidFill>
                   <a:schemeClr val="dk1"/>
@@ -30950,9 +31341,12 @@
               <a:spcAft>
                 <a:spcPts val="600"/>
               </a:spcAft>
-              <a:buSzPct val="115000"/>
-              <a:buFont typeface="Georgia"/>
-              <a:buChar char="▪"/>
+              <a:buClr>
+                <a:schemeClr val="accent1"/>
+              </a:buClr>
+              <a:buSzPct val="70000"/>
+              <a:buFont typeface="Arial"/>
+              <a:buChar char="■"/>
               <a:defRPr lang="en-US" sz="2400" dirty="0">
                 <a:solidFill>
                   <a:schemeClr val="dk1"/>
@@ -30969,9 +31363,12 @@
               <a:spcAft>
                 <a:spcPts val="600"/>
               </a:spcAft>
-              <a:buSzPct val="115000"/>
-              <a:buFont typeface="Georgia"/>
-              <a:buChar char="▪"/>
+              <a:buClr>
+                <a:schemeClr val="accent1"/>
+              </a:buClr>
+              <a:buSzPct val="70000"/>
+              <a:buFont typeface="Arial"/>
+              <a:buChar char="■"/>
               <a:defRPr lang="en-US" sz="2400" dirty="0">
                 <a:solidFill>
                   <a:schemeClr val="dk1"/>
@@ -30988,9 +31385,12 @@
               <a:spcAft>
                 <a:spcPts val="600"/>
               </a:spcAft>
-              <a:buSzPct val="115000"/>
-              <a:buFont typeface="Georgia"/>
-              <a:buChar char="▪"/>
+              <a:buClr>
+                <a:schemeClr val="accent1"/>
+              </a:buClr>
+              <a:buSzPct val="70000"/>
+              <a:buFont typeface="Arial"/>
+              <a:buChar char="■"/>
               <a:defRPr lang="en-US" sz="2400" dirty="0">
                 <a:solidFill>
                   <a:schemeClr val="dk1"/>
@@ -31007,9 +31407,12 @@
               <a:spcAft>
                 <a:spcPts val="600"/>
               </a:spcAft>
-              <a:buSzPct val="115000"/>
-              <a:buFont typeface="Georgia"/>
-              <a:buChar char="▪"/>
+              <a:buClr>
+                <a:schemeClr val="accent1"/>
+              </a:buClr>
+              <a:buSzPct val="70000"/>
+              <a:buFont typeface="Arial"/>
+              <a:buChar char="■"/>
               <a:defRPr lang="en-US" sz="2400" dirty="0">
                 <a:solidFill>
                   <a:schemeClr val="dk1"/>
@@ -31026,9 +31429,12 @@
               <a:spcAft>
                 <a:spcPts val="600"/>
               </a:spcAft>
-              <a:buSzPct val="115000"/>
-              <a:buFont typeface="Georgia"/>
-              <a:buChar char="▪"/>
+              <a:buClr>
+                <a:schemeClr val="accent1"/>
+              </a:buClr>
+              <a:buSzPct val="70000"/>
+              <a:buFont typeface="Arial"/>
+              <a:buChar char="■"/>
               <a:defRPr lang="en-US" sz="2400" dirty="0">
                 <a:solidFill>
                   <a:schemeClr val="dk1"/>
@@ -31045,9 +31451,12 @@
               <a:spcAft>
                 <a:spcPts val="600"/>
               </a:spcAft>
-              <a:buSzPct val="115000"/>
-              <a:buFont typeface="Georgia"/>
-              <a:buChar char="▪"/>
+              <a:buClr>
+                <a:schemeClr val="accent1"/>
+              </a:buClr>
+              <a:buSzPct val="70000"/>
+              <a:buFont typeface="Arial"/>
+              <a:buChar char="■"/>
               <a:defRPr lang="en-US" sz="2400" dirty="0">
                 <a:solidFill>
                   <a:schemeClr val="dk1"/>
@@ -31064,9 +31473,12 @@
               <a:spcAft>
                 <a:spcPts val="600"/>
               </a:spcAft>
-              <a:buSzPct val="115000"/>
-              <a:buFont typeface="Georgia"/>
-              <a:buChar char="▪"/>
+              <a:buClr>
+                <a:schemeClr val="accent1"/>
+              </a:buClr>
+              <a:buSzPct val="70000"/>
+              <a:buFont typeface="Arial"/>
+              <a:buChar char="■"/>
               <a:defRPr lang="en-US" sz="2400" dirty="0">
                 <a:solidFill>
                   <a:schemeClr val="dk1"/>
@@ -31083,9 +31495,12 @@
               <a:spcAft>
                 <a:spcPts val="600"/>
               </a:spcAft>
-              <a:buSzPct val="115000"/>
-              <a:buFont typeface="Georgia"/>
-              <a:buChar char="▪"/>
+              <a:buClr>
+                <a:schemeClr val="accent1"/>
+              </a:buClr>
+              <a:buSzPct val="70000"/>
+              <a:buFont typeface="Arial"/>
+              <a:buChar char="■"/>
               <a:defRPr lang="en-US" sz="2400" dirty="0">
                 <a:solidFill>
                   <a:schemeClr val="dk1"/>
@@ -31102,9 +31517,12 @@
               <a:spcAft>
                 <a:spcPts val="600"/>
               </a:spcAft>
-              <a:buSzPct val="115000"/>
-              <a:buFont typeface="Georgia"/>
-              <a:buChar char="▪"/>
+              <a:buClr>
+                <a:schemeClr val="accent1"/>
+              </a:buClr>
+              <a:buSzPct val="70000"/>
+              <a:buFont typeface="Arial"/>
+              <a:buChar char="■"/>
               <a:defRPr lang="en-US" sz="2400" dirty="0">
                 <a:solidFill>
                   <a:schemeClr val="dk1"/>
@@ -31123,9 +31541,12 @@
               <a:spcAft>
                 <a:spcPts val="600"/>
               </a:spcAft>
-              <a:buSzPct val="115000"/>
-              <a:buFont typeface="Georgia"/>
-              <a:buChar char="▪"/>
+              <a:buClr>
+                <a:schemeClr val="accent1"/>
+              </a:buClr>
+              <a:buSzPct val="70000"/>
+              <a:buFont typeface="Arial"/>
+              <a:buChar char="■"/>
               <a:defRPr lang="en-US" sz="2400" dirty="0">
                 <a:solidFill>
                   <a:schemeClr val="dk1"/>
@@ -31163,9 +31584,12 @@
               <a:spcAft>
                 <a:spcPts val="600"/>
               </a:spcAft>
-              <a:buSzPct val="115000"/>
-              <a:buFont typeface="Georgia"/>
-              <a:buChar char="▪"/>
+              <a:buClr>
+                <a:schemeClr val="accent1"/>
+              </a:buClr>
+              <a:buSzPct val="70000"/>
+              <a:buFont typeface="Arial"/>
+              <a:buChar char="■"/>
               <a:defRPr lang="en-US" sz="2400" dirty="0">
                 <a:solidFill>
                   <a:schemeClr val="dk1"/>
@@ -31203,9 +31627,12 @@
               <a:spcAft>
                 <a:spcPts val="600"/>
               </a:spcAft>
-              <a:buSzPct val="115000"/>
-              <a:buFont typeface="Georgia"/>
-              <a:buChar char="▪"/>
+              <a:buClr>
+                <a:schemeClr val="accent1"/>
+              </a:buClr>
+              <a:buSzPct val="70000"/>
+              <a:buFont typeface="Arial"/>
+              <a:buChar char="■"/>
               <a:defRPr lang="en-US" sz="2400" dirty="0">
                 <a:solidFill>
                   <a:schemeClr val="dk1"/>
@@ -31480,9 +31907,12 @@
               <a:spcAft>
                 <a:spcPts val="600"/>
               </a:spcAft>
-              <a:buSzPct val="115000"/>
-              <a:buFont typeface="Georgia"/>
-              <a:buChar char="▪"/>
+              <a:buClr>
+                <a:schemeClr val="accent1"/>
+              </a:buClr>
+              <a:buSzPct val="70000"/>
+              <a:buFont typeface="Arial"/>
+              <a:buChar char="■"/>
               <a:defRPr lang="en-US" sz="2400" dirty="0">
                 <a:solidFill>
                   <a:schemeClr val="dk1"/>
@@ -31499,9 +31929,12 @@
               <a:spcAft>
                 <a:spcPts val="600"/>
               </a:spcAft>
-              <a:buSzPct val="115000"/>
-              <a:buFont typeface="Georgia"/>
-              <a:buChar char="▪"/>
+              <a:buClr>
+                <a:schemeClr val="accent1"/>
+              </a:buClr>
+              <a:buSzPct val="70000"/>
+              <a:buFont typeface="Arial"/>
+              <a:buChar char="■"/>
               <a:defRPr lang="en-US" sz="2400" dirty="0">
                 <a:solidFill>
                   <a:schemeClr val="dk1"/>
@@ -31518,9 +31951,12 @@
               <a:spcAft>
                 <a:spcPts val="600"/>
               </a:spcAft>
-              <a:buSzPct val="115000"/>
-              <a:buFont typeface="Georgia"/>
-              <a:buChar char="▪"/>
+              <a:buClr>
+                <a:schemeClr val="accent1"/>
+              </a:buClr>
+              <a:buSzPct val="70000"/>
+              <a:buFont typeface="Arial"/>
+              <a:buChar char="■"/>
               <a:defRPr lang="en-US" sz="2400" dirty="0">
                 <a:solidFill>
                   <a:schemeClr val="dk1"/>
@@ -31537,9 +31973,12 @@
               <a:spcAft>
                 <a:spcPts val="600"/>
               </a:spcAft>
-              <a:buSzPct val="115000"/>
-              <a:buFont typeface="Georgia"/>
-              <a:buChar char="▪"/>
+              <a:buClr>
+                <a:schemeClr val="accent1"/>
+              </a:buClr>
+              <a:buSzPct val="70000"/>
+              <a:buFont typeface="Arial"/>
+              <a:buChar char="■"/>
               <a:defRPr lang="en-US" sz="2400" dirty="0">
                 <a:solidFill>
                   <a:schemeClr val="dk1"/>
@@ -31556,9 +31995,12 @@
               <a:spcAft>
                 <a:spcPts val="600"/>
               </a:spcAft>
-              <a:buSzPct val="115000"/>
-              <a:buFont typeface="Georgia"/>
-              <a:buChar char="▪"/>
+              <a:buClr>
+                <a:schemeClr val="accent1"/>
+              </a:buClr>
+              <a:buSzPct val="70000"/>
+              <a:buFont typeface="Arial"/>
+              <a:buChar char="■"/>
               <a:defRPr lang="en-US" sz="2400" dirty="0">
                 <a:solidFill>
                   <a:schemeClr val="dk1"/>
@@ -31575,9 +32017,12 @@
               <a:spcAft>
                 <a:spcPts val="600"/>
               </a:spcAft>
-              <a:buSzPct val="115000"/>
-              <a:buFont typeface="Georgia"/>
-              <a:buChar char="▪"/>
+              <a:buClr>
+                <a:schemeClr val="accent1"/>
+              </a:buClr>
+              <a:buSzPct val="70000"/>
+              <a:buFont typeface="Arial"/>
+              <a:buChar char="■"/>
               <a:defRPr lang="en-US" sz="2400" dirty="0">
                 <a:solidFill>
                   <a:schemeClr val="dk1"/>
@@ -31594,9 +32039,12 @@
               <a:spcAft>
                 <a:spcPts val="600"/>
               </a:spcAft>
-              <a:buSzPct val="115000"/>
-              <a:buFont typeface="Georgia"/>
-              <a:buChar char="▪"/>
+              <a:buClr>
+                <a:schemeClr val="accent1"/>
+              </a:buClr>
+              <a:buSzPct val="70000"/>
+              <a:buFont typeface="Arial"/>
+              <a:buChar char="■"/>
               <a:defRPr lang="en-US" sz="2400" dirty="0">
                 <a:solidFill>
                   <a:schemeClr val="dk1"/>
@@ -31613,9 +32061,12 @@
               <a:spcAft>
                 <a:spcPts val="600"/>
               </a:spcAft>
-              <a:buSzPct val="115000"/>
-              <a:buFont typeface="Georgia"/>
-              <a:buChar char="▪"/>
+              <a:buClr>
+                <a:schemeClr val="accent1"/>
+              </a:buClr>
+              <a:buSzPct val="70000"/>
+              <a:buFont typeface="Arial"/>
+              <a:buChar char="■"/>
               <a:defRPr lang="en-US" sz="2400" dirty="0">
                 <a:solidFill>
                   <a:schemeClr val="dk1"/>
@@ -31632,9 +32083,12 @@
               <a:spcAft>
                 <a:spcPts val="600"/>
               </a:spcAft>
-              <a:buSzPct val="115000"/>
-              <a:buFont typeface="Georgia"/>
-              <a:buChar char="▪"/>
+              <a:buClr>
+                <a:schemeClr val="accent1"/>
+              </a:buClr>
+              <a:buSzPct val="70000"/>
+              <a:buFont typeface="Arial"/>
+              <a:buChar char="■"/>
               <a:defRPr lang="en-US" sz="2400" dirty="0">
                 <a:solidFill>
                   <a:schemeClr val="dk1"/>
@@ -31651,9 +32105,12 @@
               <a:spcAft>
                 <a:spcPts val="600"/>
               </a:spcAft>
-              <a:buSzPct val="115000"/>
-              <a:buFont typeface="Georgia"/>
-              <a:buChar char="▪"/>
+              <a:buClr>
+                <a:schemeClr val="accent1"/>
+              </a:buClr>
+              <a:buSzPct val="70000"/>
+              <a:buFont typeface="Arial"/>
+              <a:buChar char="■"/>
               <a:defRPr lang="en-US" sz="2400" dirty="0">
                 <a:solidFill>
                   <a:schemeClr val="dk1"/>
@@ -31672,9 +32129,12 @@
               <a:spcAft>
                 <a:spcPts val="600"/>
               </a:spcAft>
-              <a:buSzPct val="115000"/>
-              <a:buFont typeface="Georgia"/>
-              <a:buChar char="▪"/>
+              <a:buClr>
+                <a:schemeClr val="accent1"/>
+              </a:buClr>
+              <a:buSzPct val="70000"/>
+              <a:buFont typeface="Arial"/>
+              <a:buChar char="■"/>
               <a:defRPr lang="en-US" sz="2400" dirty="0">
                 <a:solidFill>
                   <a:schemeClr val="dk1"/>
@@ -31712,9 +32172,12 @@
               <a:spcAft>
                 <a:spcPts val="600"/>
               </a:spcAft>
-              <a:buSzPct val="115000"/>
-              <a:buFont typeface="Georgia"/>
-              <a:buChar char="▪"/>
+              <a:buClr>
+                <a:schemeClr val="accent1"/>
+              </a:buClr>
+              <a:buSzPct val="70000"/>
+              <a:buFont typeface="Arial"/>
+              <a:buChar char="■"/>
               <a:defRPr lang="en-US" sz="2400" dirty="0">
                 <a:solidFill>
                   <a:schemeClr val="dk1"/>
@@ -31752,9 +32215,12 @@
               <a:spcAft>
                 <a:spcPts val="600"/>
               </a:spcAft>
-              <a:buSzPct val="115000"/>
-              <a:buFont typeface="Georgia"/>
-              <a:buChar char="▪"/>
+              <a:buClr>
+                <a:schemeClr val="accent1"/>
+              </a:buClr>
+              <a:buSzPct val="70000"/>
+              <a:buFont typeface="Arial"/>
+              <a:buChar char="■"/>
               <a:defRPr lang="en-US" sz="2400" dirty="0">
                 <a:solidFill>
                   <a:schemeClr val="dk1"/>
@@ -35271,9 +35737,12 @@
               <a:spcAft>
                 <a:spcPts val="600"/>
               </a:spcAft>
-              <a:buSzPct val="115000"/>
-              <a:buFont typeface="Georgia"/>
-              <a:buChar char="▪"/>
+              <a:buClr>
+                <a:schemeClr val="accent1"/>
+              </a:buClr>
+              <a:buSzPct val="70000"/>
+              <a:buFont typeface="Arial"/>
+              <a:buChar char="■"/>
               <a:defRPr lang="en-US" sz="2400" dirty="0">
                 <a:solidFill>
                   <a:schemeClr val="dk1"/>
@@ -35290,9 +35759,12 @@
               <a:spcAft>
                 <a:spcPts val="600"/>
               </a:spcAft>
-              <a:buSzPct val="115000"/>
-              <a:buFont typeface="Georgia"/>
-              <a:buChar char="▪"/>
+              <a:buClr>
+                <a:schemeClr val="accent1"/>
+              </a:buClr>
+              <a:buSzPct val="70000"/>
+              <a:buFont typeface="Arial"/>
+              <a:buChar char="■"/>
               <a:defRPr lang="en-US" sz="2400" dirty="0">
                 <a:solidFill>
                   <a:schemeClr val="dk1"/>
@@ -35309,9 +35781,12 @@
               <a:spcAft>
                 <a:spcPts val="600"/>
               </a:spcAft>
-              <a:buSzPct val="115000"/>
-              <a:buFont typeface="Georgia"/>
-              <a:buChar char="▪"/>
+              <a:buClr>
+                <a:schemeClr val="accent1"/>
+              </a:buClr>
+              <a:buSzPct val="70000"/>
+              <a:buFont typeface="Arial"/>
+              <a:buChar char="■"/>
               <a:defRPr lang="en-US" sz="2400" dirty="0">
                 <a:solidFill>
                   <a:schemeClr val="dk1"/>
@@ -35328,9 +35803,12 @@
               <a:spcAft>
                 <a:spcPts val="600"/>
               </a:spcAft>
-              <a:buSzPct val="115000"/>
-              <a:buFont typeface="Georgia"/>
-              <a:buChar char="▪"/>
+              <a:buClr>
+                <a:schemeClr val="accent1"/>
+              </a:buClr>
+              <a:buSzPct val="70000"/>
+              <a:buFont typeface="Arial"/>
+              <a:buChar char="■"/>
               <a:defRPr lang="en-US" sz="2400" dirty="0">
                 <a:solidFill>
                   <a:schemeClr val="dk1"/>
@@ -35347,9 +35825,12 @@
               <a:spcAft>
                 <a:spcPts val="600"/>
               </a:spcAft>
-              <a:buSzPct val="115000"/>
-              <a:buFont typeface="Georgia"/>
-              <a:buChar char="▪"/>
+              <a:buClr>
+                <a:schemeClr val="accent1"/>
+              </a:buClr>
+              <a:buSzPct val="70000"/>
+              <a:buFont typeface="Arial"/>
+              <a:buChar char="■"/>
               <a:defRPr lang="en-US" sz="2400" dirty="0">
                 <a:solidFill>
                   <a:schemeClr val="dk1"/>
@@ -35366,9 +35847,12 @@
               <a:spcAft>
                 <a:spcPts val="600"/>
               </a:spcAft>
-              <a:buSzPct val="115000"/>
-              <a:buFont typeface="Georgia"/>
-              <a:buChar char="▪"/>
+              <a:buClr>
+                <a:schemeClr val="accent1"/>
+              </a:buClr>
+              <a:buSzPct val="70000"/>
+              <a:buFont typeface="Arial"/>
+              <a:buChar char="■"/>
               <a:defRPr lang="en-US" sz="2400" dirty="0">
                 <a:solidFill>
                   <a:schemeClr val="dk1"/>
@@ -35385,9 +35869,12 @@
               <a:spcAft>
                 <a:spcPts val="600"/>
               </a:spcAft>
-              <a:buSzPct val="115000"/>
-              <a:buFont typeface="Georgia"/>
-              <a:buChar char="▪"/>
+              <a:buClr>
+                <a:schemeClr val="accent1"/>
+              </a:buClr>
+              <a:buSzPct val="70000"/>
+              <a:buFont typeface="Arial"/>
+              <a:buChar char="■"/>
               <a:defRPr lang="en-US" sz="2400" dirty="0">
                 <a:solidFill>
                   <a:schemeClr val="dk1"/>
@@ -35404,9 +35891,12 @@
               <a:spcAft>
                 <a:spcPts val="600"/>
               </a:spcAft>
-              <a:buSzPct val="115000"/>
-              <a:buFont typeface="Georgia"/>
-              <a:buChar char="▪"/>
+              <a:buClr>
+                <a:schemeClr val="accent1"/>
+              </a:buClr>
+              <a:buSzPct val="70000"/>
+              <a:buFont typeface="Arial"/>
+              <a:buChar char="■"/>
               <a:defRPr lang="en-US" sz="2400" dirty="0">
                 <a:solidFill>
                   <a:schemeClr val="dk1"/>
@@ -35423,9 +35913,12 @@
               <a:spcAft>
                 <a:spcPts val="600"/>
               </a:spcAft>
-              <a:buSzPct val="115000"/>
-              <a:buFont typeface="Georgia"/>
-              <a:buChar char="▪"/>
+              <a:buClr>
+                <a:schemeClr val="accent1"/>
+              </a:buClr>
+              <a:buSzPct val="70000"/>
+              <a:buFont typeface="Arial"/>
+              <a:buChar char="■"/>
               <a:defRPr lang="en-US" sz="2400" dirty="0">
                 <a:solidFill>
                   <a:schemeClr val="dk1"/>
@@ -35442,9 +35935,12 @@
               <a:spcAft>
                 <a:spcPts val="600"/>
               </a:spcAft>
-              <a:buSzPct val="115000"/>
-              <a:buFont typeface="Georgia"/>
-              <a:buChar char="▪"/>
+              <a:buClr>
+                <a:schemeClr val="accent1"/>
+              </a:buClr>
+              <a:buSzPct val="70000"/>
+              <a:buFont typeface="Arial"/>
+              <a:buChar char="■"/>
               <a:defRPr lang="en-US" sz="2400" dirty="0">
                 <a:solidFill>
                   <a:schemeClr val="dk1"/>
@@ -35463,9 +35959,12 @@
               <a:spcAft>
                 <a:spcPts val="600"/>
               </a:spcAft>
-              <a:buSzPct val="115000"/>
-              <a:buFont typeface="Georgia"/>
-              <a:buChar char="▪"/>
+              <a:buClr>
+                <a:schemeClr val="accent1"/>
+              </a:buClr>
+              <a:buSzPct val="70000"/>
+              <a:buFont typeface="Arial"/>
+              <a:buChar char="■"/>
               <a:defRPr lang="en-US" sz="2400" dirty="0">
                 <a:solidFill>
                   <a:schemeClr val="dk1"/>
@@ -35503,9 +36002,12 @@
               <a:spcAft>
                 <a:spcPts val="600"/>
               </a:spcAft>
-              <a:buSzPct val="115000"/>
-              <a:buFont typeface="Georgia"/>
-              <a:buChar char="▪"/>
+              <a:buClr>
+                <a:schemeClr val="accent1"/>
+              </a:buClr>
+              <a:buSzPct val="70000"/>
+              <a:buFont typeface="Arial"/>
+              <a:buChar char="■"/>
               <a:defRPr lang="en-US" sz="2400" dirty="0">
                 <a:solidFill>
                   <a:schemeClr val="dk1"/>
@@ -35543,9 +36045,12 @@
               <a:spcAft>
                 <a:spcPts val="600"/>
               </a:spcAft>
-              <a:buSzPct val="115000"/>
-              <a:buFont typeface="Georgia"/>
-              <a:buChar char="▪"/>
+              <a:buClr>
+                <a:schemeClr val="accent1"/>
+              </a:buClr>
+              <a:buSzPct val="70000"/>
+              <a:buFont typeface="Arial"/>
+              <a:buChar char="■"/>
               <a:defRPr lang="en-US" sz="2400" dirty="0">
                 <a:solidFill>
                   <a:schemeClr val="dk1"/>
@@ -35583,9 +36088,12 @@
               <a:spcAft>
                 <a:spcPts val="600"/>
               </a:spcAft>
-              <a:buSzPct val="115000"/>
-              <a:buFont typeface="Georgia"/>
-              <a:buChar char="▪"/>
+              <a:buClr>
+                <a:schemeClr val="accent1"/>
+              </a:buClr>
+              <a:buSzPct val="70000"/>
+              <a:buFont typeface="Arial"/>
+              <a:buChar char="■"/>
               <a:defRPr lang="en-US" sz="2400" dirty="0">
                 <a:solidFill>
                   <a:schemeClr val="dk1"/>

</xml_diff>